<commit_message>
Maj management et présentation
</commit_message>
<xml_diff>
--- a/presentation/dsfs_ft_35_Projet_REnergies_efficiency_prediction.pptx
+++ b/presentation/dsfs_ft_35_Projet_REnergies_efficiency_prediction.pptx
@@ -6,42 +6,41 @@
     <p:sldMasterId id="2147483660" r:id="rId2"/>
   </p:sldMasterIdLst>
   <p:notesMasterIdLst>
-    <p:notesMasterId r:id="rId12"/>
+    <p:notesMasterId r:id="rId11"/>
   </p:notesMasterIdLst>
   <p:sldIdLst>
     <p:sldId id="256" r:id="rId3"/>
     <p:sldId id="263" r:id="rId4"/>
     <p:sldId id="286" r:id="rId5"/>
-    <p:sldId id="272" r:id="rId6"/>
+    <p:sldId id="274" r:id="rId6"/>
     <p:sldId id="270" r:id="rId7"/>
     <p:sldId id="273" r:id="rId8"/>
-    <p:sldId id="274" r:id="rId9"/>
-    <p:sldId id="275" r:id="rId10"/>
-    <p:sldId id="271" r:id="rId11"/>
+    <p:sldId id="275" r:id="rId9"/>
+    <p:sldId id="271" r:id="rId10"/>
   </p:sldIdLst>
   <p:sldSz cx="9144000" cy="5143500" type="screen16x9"/>
   <p:notesSz cx="6858000" cy="9144000"/>
   <p:embeddedFontLst>
     <p:embeddedFont>
       <p:font typeface="Inter" panose="020B0604020202020204" charset="0"/>
-      <p:regular r:id="rId13"/>
-      <p:bold r:id="rId14"/>
-      <p:italic r:id="rId15"/>
-      <p:boldItalic r:id="rId16"/>
+      <p:regular r:id="rId12"/>
+      <p:bold r:id="rId13"/>
+      <p:italic r:id="rId14"/>
+      <p:boldItalic r:id="rId15"/>
     </p:embeddedFont>
     <p:embeddedFont>
       <p:font typeface="Inter Medium" panose="020B0604020202020204" charset="0"/>
-      <p:regular r:id="rId17"/>
-      <p:bold r:id="rId18"/>
-      <p:italic r:id="rId19"/>
-      <p:boldItalic r:id="rId20"/>
+      <p:regular r:id="rId16"/>
+      <p:bold r:id="rId17"/>
+      <p:italic r:id="rId18"/>
+      <p:boldItalic r:id="rId19"/>
     </p:embeddedFont>
     <p:embeddedFont>
       <p:font typeface="Inter SemiBold" panose="020B0604020202020204" charset="0"/>
-      <p:regular r:id="rId21"/>
-      <p:bold r:id="rId22"/>
-      <p:italic r:id="rId23"/>
-      <p:boldItalic r:id="rId24"/>
+      <p:regular r:id="rId20"/>
+      <p:bold r:id="rId21"/>
+      <p:italic r:id="rId22"/>
+      <p:boldItalic r:id="rId23"/>
     </p:embeddedFont>
   </p:embeddedFontLst>
   <p:defaultTextStyle>
@@ -284,7 +283,7 @@
 <file path=ppt/revisionInfo.xml><?xml version="1.0" encoding="utf-8"?>
 <p1510:revInfo xmlns:a="http://schemas.openxmlformats.org/drawingml/2006/main" xmlns:r="http://schemas.openxmlformats.org/officeDocument/2006/relationships" xmlns:p1510="http://schemas.microsoft.com/office/powerpoint/2015/10/main">
   <p1510:revLst>
-    <p1510:client id="{2EB72A00-7F79-4813-B4C2-C6564860F3F6}" v="18" dt="2025-11-19T11:01:06.060"/>
+    <p1510:client id="{2EB72A00-7F79-4813-B4C2-C6564860F3F6}" v="61" dt="2025-11-19T15:31:23.621"/>
   </p1510:revLst>
 </p1510:revInfo>
 </file>
@@ -294,7 +293,7 @@
   <pc:docChgLst>
     <pc:chgData name="Jean-Yves Vuillequez" userId="e7fac481abea6bd0" providerId="LiveId" clId="{79E365E8-22BC-4EC2-9606-9A9AC6CD1D22}"/>
     <pc:docChg chg="undo custSel addSld delSld modSld sldOrd">
-      <pc:chgData name="Jean-Yves Vuillequez" userId="e7fac481abea6bd0" providerId="LiveId" clId="{79E365E8-22BC-4EC2-9606-9A9AC6CD1D22}" dt="2025-11-19T11:06:52.762" v="118"/>
+      <pc:chgData name="Jean-Yves Vuillequez" userId="e7fac481abea6bd0" providerId="LiveId" clId="{79E365E8-22BC-4EC2-9606-9A9AC6CD1D22}" dt="2025-11-19T15:31:23.550" v="194" actId="1076"/>
       <pc:docMkLst>
         <pc:docMk/>
       </pc:docMkLst>
@@ -373,11 +372,27 @@
         </pc:sldMkLst>
       </pc:sldChg>
       <pc:sldChg chg="addSp delSp modSp mod">
-        <pc:chgData name="Jean-Yves Vuillequez" userId="e7fac481abea6bd0" providerId="LiveId" clId="{79E365E8-22BC-4EC2-9606-9A9AC6CD1D22}" dt="2025-11-19T11:04:20.428" v="92" actId="22"/>
+        <pc:chgData name="Jean-Yves Vuillequez" userId="e7fac481abea6bd0" providerId="LiveId" clId="{79E365E8-22BC-4EC2-9606-9A9AC6CD1D22}" dt="2025-11-19T15:27:31.625" v="178" actId="22"/>
         <pc:sldMkLst>
           <pc:docMk/>
           <pc:sldMk cId="0" sldId="270"/>
         </pc:sldMkLst>
+        <pc:spChg chg="add del">
+          <ac:chgData name="Jean-Yves Vuillequez" userId="e7fac481abea6bd0" providerId="LiveId" clId="{79E365E8-22BC-4EC2-9606-9A9AC6CD1D22}" dt="2025-11-19T15:27:31.625" v="178" actId="22"/>
+          <ac:spMkLst>
+            <pc:docMk/>
+            <pc:sldMk cId="0" sldId="270"/>
+            <ac:spMk id="5" creationId="{CFDEE9DF-9D18-D97C-5C14-CA1236A83E99}"/>
+          </ac:spMkLst>
+        </pc:spChg>
+        <pc:spChg chg="mod">
+          <ac:chgData name="Jean-Yves Vuillequez" userId="e7fac481abea6bd0" providerId="LiveId" clId="{79E365E8-22BC-4EC2-9606-9A9AC6CD1D22}" dt="2025-11-19T14:03:00.878" v="125" actId="108"/>
+          <ac:spMkLst>
+            <pc:docMk/>
+            <pc:sldMk cId="0" sldId="270"/>
+            <ac:spMk id="178" creationId="{00000000-0000-0000-0000-000000000000}"/>
+          </ac:spMkLst>
+        </pc:spChg>
         <pc:spChg chg="mod">
           <ac:chgData name="Jean-Yves Vuillequez" userId="e7fac481abea6bd0" providerId="LiveId" clId="{79E365E8-22BC-4EC2-9606-9A9AC6CD1D22}" dt="2025-11-19T11:00:50.475" v="83" actId="14100"/>
           <ac:spMkLst>
@@ -403,19 +418,34 @@
           </ac:picMkLst>
         </pc:picChg>
       </pc:sldChg>
-      <pc:sldChg chg="add">
-        <pc:chgData name="Jean-Yves Vuillequez" userId="e7fac481abea6bd0" providerId="LiveId" clId="{79E365E8-22BC-4EC2-9606-9A9AC6CD1D22}" dt="2025-11-19T11:00:33.442" v="74"/>
+      <pc:sldChg chg="del">
+        <pc:chgData name="Jean-Yves Vuillequez" userId="e7fac481abea6bd0" providerId="LiveId" clId="{79E365E8-22BC-4EC2-9606-9A9AC6CD1D22}" dt="2025-11-19T14:02:01.719" v="119" actId="47"/>
+        <pc:sldMkLst>
+          <pc:docMk/>
+          <pc:sldMk cId="2182015625" sldId="272"/>
+        </pc:sldMkLst>
+      </pc:sldChg>
+      <pc:sldChg chg="add del">
+        <pc:chgData name="Jean-Yves Vuillequez" userId="e7fac481abea6bd0" providerId="LiveId" clId="{79E365E8-22BC-4EC2-9606-9A9AC6CD1D22}" dt="2025-11-19T14:02:17.709" v="121" actId="47"/>
         <pc:sldMkLst>
           <pc:docMk/>
           <pc:sldMk cId="1023234914" sldId="273"/>
         </pc:sldMkLst>
       </pc:sldChg>
-      <pc:sldChg chg="del">
-        <pc:chgData name="Jean-Yves Vuillequez" userId="e7fac481abea6bd0" providerId="LiveId" clId="{79E365E8-22BC-4EC2-9606-9A9AC6CD1D22}" dt="2025-11-19T11:00:27.703" v="73" actId="2696"/>
+      <pc:sldChg chg="modSp add del mod">
+        <pc:chgData name="Jean-Yves Vuillequez" userId="e7fac481abea6bd0" providerId="LiveId" clId="{79E365E8-22BC-4EC2-9606-9A9AC6CD1D22}" dt="2025-11-19T14:03:57.617" v="139" actId="20577"/>
         <pc:sldMkLst>
           <pc:docMk/>
           <pc:sldMk cId="1558646683" sldId="273"/>
         </pc:sldMkLst>
+        <pc:spChg chg="mod">
+          <ac:chgData name="Jean-Yves Vuillequez" userId="e7fac481abea6bd0" providerId="LiveId" clId="{79E365E8-22BC-4EC2-9606-9A9AC6CD1D22}" dt="2025-11-19T14:03:57.617" v="139" actId="20577"/>
+          <ac:spMkLst>
+            <pc:docMk/>
+            <pc:sldMk cId="1558646683" sldId="273"/>
+            <ac:spMk id="62" creationId="{1465D56F-7913-AD4E-8248-AEC9AC3FBC16}"/>
+          </ac:spMkLst>
+        </pc:spChg>
       </pc:sldChg>
       <pc:sldChg chg="delSp modSp del mod delAnim">
         <pc:chgData name="Jean-Yves Vuillequez" userId="e7fac481abea6bd0" providerId="LiveId" clId="{79E365E8-22BC-4EC2-9606-9A9AC6CD1D22}" dt="2025-11-19T11:00:27.703" v="73" actId="2696"/>
@@ -536,18 +566,98 @@
           </ac:spMkLst>
         </pc:spChg>
       </pc:sldChg>
-      <pc:sldChg chg="addSp modSp add mod">
-        <pc:chgData name="Jean-Yves Vuillequez" userId="e7fac481abea6bd0" providerId="LiveId" clId="{79E365E8-22BC-4EC2-9606-9A9AC6CD1D22}" dt="2025-11-19T11:04:39.897" v="116" actId="1037"/>
+      <pc:sldChg chg="addSp delSp modSp add mod ord">
+        <pc:chgData name="Jean-Yves Vuillequez" userId="e7fac481abea6bd0" providerId="LiveId" clId="{79E365E8-22BC-4EC2-9606-9A9AC6CD1D22}" dt="2025-11-19T15:31:23.550" v="194" actId="1076"/>
         <pc:sldMkLst>
           <pc:docMk/>
           <pc:sldMk cId="1821755839" sldId="274"/>
         </pc:sldMkLst>
+        <pc:spChg chg="add del">
+          <ac:chgData name="Jean-Yves Vuillequez" userId="e7fac481abea6bd0" providerId="LiveId" clId="{79E365E8-22BC-4EC2-9606-9A9AC6CD1D22}" dt="2025-11-19T15:21:25.434" v="149" actId="22"/>
+          <ac:spMkLst>
+            <pc:docMk/>
+            <pc:sldMk cId="1821755839" sldId="274"/>
+            <ac:spMk id="5" creationId="{42ECEDB8-E4FE-DAD1-959E-CE1C852FF3B7}"/>
+          </ac:spMkLst>
+        </pc:spChg>
+        <pc:spChg chg="add del">
+          <ac:chgData name="Jean-Yves Vuillequez" userId="e7fac481abea6bd0" providerId="LiveId" clId="{79E365E8-22BC-4EC2-9606-9A9AC6CD1D22}" dt="2025-11-19T15:25:59.512" v="172" actId="22"/>
+          <ac:spMkLst>
+            <pc:docMk/>
+            <pc:sldMk cId="1821755839" sldId="274"/>
+            <ac:spMk id="7" creationId="{A1088045-42F5-FD97-ED83-6AEF73316F36}"/>
+          </ac:spMkLst>
+        </pc:spChg>
+        <pc:spChg chg="add del">
+          <ac:chgData name="Jean-Yves Vuillequez" userId="e7fac481abea6bd0" providerId="LiveId" clId="{79E365E8-22BC-4EC2-9606-9A9AC6CD1D22}" dt="2025-11-19T15:31:05.378" v="184" actId="22"/>
+          <ac:spMkLst>
+            <pc:docMk/>
+            <pc:sldMk cId="1821755839" sldId="274"/>
+            <ac:spMk id="9" creationId="{C85936DC-7A36-C7FD-89BC-2AF218A582C2}"/>
+          </ac:spMkLst>
+        </pc:spChg>
         <pc:picChg chg="add mod">
-          <ac:chgData name="Jean-Yves Vuillequez" userId="e7fac481abea6bd0" providerId="LiveId" clId="{79E365E8-22BC-4EC2-9606-9A9AC6CD1D22}" dt="2025-11-19T11:04:39.897" v="116" actId="1037"/>
+          <ac:chgData name="Jean-Yves Vuillequez" userId="e7fac481abea6bd0" providerId="LiveId" clId="{79E365E8-22BC-4EC2-9606-9A9AC6CD1D22}" dt="2025-11-19T15:07:19.367" v="147" actId="1076"/>
           <ac:picMkLst>
             <pc:docMk/>
             <pc:sldMk cId="1821755839" sldId="274"/>
             <ac:picMk id="3" creationId="{B2469126-D060-A3A0-24FE-3940B83EED58}"/>
+          </ac:picMkLst>
+        </pc:picChg>
+        <pc:picChg chg="add mod">
+          <ac:chgData name="Jean-Yves Vuillequez" userId="e7fac481abea6bd0" providerId="LiveId" clId="{79E365E8-22BC-4EC2-9606-9A9AC6CD1D22}" dt="2025-11-19T15:31:23.550" v="194" actId="1076"/>
+          <ac:picMkLst>
+            <pc:docMk/>
+            <pc:sldMk cId="1821755839" sldId="274"/>
+            <ac:picMk id="1026" creationId="{923FE2F2-F305-A7CE-975B-2A2BA912E4B7}"/>
+          </ac:picMkLst>
+        </pc:picChg>
+        <pc:picChg chg="add mod">
+          <ac:chgData name="Jean-Yves Vuillequez" userId="e7fac481abea6bd0" providerId="LiveId" clId="{79E365E8-22BC-4EC2-9606-9A9AC6CD1D22}" dt="2025-11-19T15:31:22.560" v="193" actId="1076"/>
+          <ac:picMkLst>
+            <pc:docMk/>
+            <pc:sldMk cId="1821755839" sldId="274"/>
+            <ac:picMk id="1028" creationId="{D0C03EA7-EAD6-1A33-21AE-920B9121582F}"/>
+          </ac:picMkLst>
+        </pc:picChg>
+        <pc:picChg chg="add mod">
+          <ac:chgData name="Jean-Yves Vuillequez" userId="e7fac481abea6bd0" providerId="LiveId" clId="{79E365E8-22BC-4EC2-9606-9A9AC6CD1D22}" dt="2025-11-19T15:31:21.682" v="192" actId="1076"/>
+          <ac:picMkLst>
+            <pc:docMk/>
+            <pc:sldMk cId="1821755839" sldId="274"/>
+            <ac:picMk id="1030" creationId="{2941D76B-6840-C572-907F-F3680B66EBF7}"/>
+          </ac:picMkLst>
+        </pc:picChg>
+        <pc:picChg chg="add mod">
+          <ac:chgData name="Jean-Yves Vuillequez" userId="e7fac481abea6bd0" providerId="LiveId" clId="{79E365E8-22BC-4EC2-9606-9A9AC6CD1D22}" dt="2025-11-19T15:31:20.951" v="191" actId="1076"/>
+          <ac:picMkLst>
+            <pc:docMk/>
+            <pc:sldMk cId="1821755839" sldId="274"/>
+            <ac:picMk id="1032" creationId="{0AA62D0C-7533-F64F-5205-AC2C6EB164FE}"/>
+          </ac:picMkLst>
+        </pc:picChg>
+        <pc:picChg chg="add mod">
+          <ac:chgData name="Jean-Yves Vuillequez" userId="e7fac481abea6bd0" providerId="LiveId" clId="{79E365E8-22BC-4EC2-9606-9A9AC6CD1D22}" dt="2025-11-19T15:31:20.132" v="190" actId="1076"/>
+          <ac:picMkLst>
+            <pc:docMk/>
+            <pc:sldMk cId="1821755839" sldId="274"/>
+            <ac:picMk id="1034" creationId="{748B16F9-6C53-91C1-4712-424BF6CE8989}"/>
+          </ac:picMkLst>
+        </pc:picChg>
+        <pc:picChg chg="add mod">
+          <ac:chgData name="Jean-Yves Vuillequez" userId="e7fac481abea6bd0" providerId="LiveId" clId="{79E365E8-22BC-4EC2-9606-9A9AC6CD1D22}" dt="2025-11-19T15:31:19.120" v="189" actId="1076"/>
+          <ac:picMkLst>
+            <pc:docMk/>
+            <pc:sldMk cId="1821755839" sldId="274"/>
+            <ac:picMk id="1036" creationId="{135630BC-F5F0-17C1-438A-A312C16997F8}"/>
+          </ac:picMkLst>
+        </pc:picChg>
+        <pc:picChg chg="add mod">
+          <ac:chgData name="Jean-Yves Vuillequez" userId="e7fac481abea6bd0" providerId="LiveId" clId="{79E365E8-22BC-4EC2-9606-9A9AC6CD1D22}" dt="2025-11-19T15:31:17.953" v="188" actId="1076"/>
+          <ac:picMkLst>
+            <pc:docMk/>
+            <pc:sldMk cId="1821755839" sldId="274"/>
+            <ac:picMk id="1038" creationId="{1B3822DD-A0E9-A37F-0DE9-40781F1C3DF4}"/>
           </ac:picMkLst>
         </pc:picChg>
       </pc:sldChg>
@@ -575,7 +685,7 @@
         </pc:graphicFrameChg>
       </pc:sldChg>
       <pc:sldChg chg="addSp delSp modSp add mod ord">
-        <pc:chgData name="Jean-Yves Vuillequez" userId="e7fac481abea6bd0" providerId="LiveId" clId="{79E365E8-22BC-4EC2-9606-9A9AC6CD1D22}" dt="2025-11-19T11:06:52.762" v="118"/>
+        <pc:chgData name="Jean-Yves Vuillequez" userId="e7fac481abea6bd0" providerId="LiveId" clId="{79E365E8-22BC-4EC2-9606-9A9AC6CD1D22}" dt="2025-11-19T14:03:15.846" v="127"/>
         <pc:sldMkLst>
           <pc:docMk/>
           <pc:sldMk cId="4088050223" sldId="275"/>
@@ -654,46 +764,70 @@
           <pc:sldMk cId="2602082869" sldId="285"/>
         </pc:sldMkLst>
       </pc:sldChg>
-      <pc:sldChg chg="delSp modSp mod delAnim">
-        <pc:chgData name="Jean-Yves Vuillequez" userId="e7fac481abea6bd0" providerId="LiveId" clId="{79E365E8-22BC-4EC2-9606-9A9AC6CD1D22}" dt="2025-11-19T10:59:24.012" v="72" actId="1076"/>
+      <pc:sldChg chg="addSp delSp modSp mod delAnim">
+        <pc:chgData name="Jean-Yves Vuillequez" userId="e7fac481abea6bd0" providerId="LiveId" clId="{79E365E8-22BC-4EC2-9606-9A9AC6CD1D22}" dt="2025-11-19T15:04:11.263" v="144"/>
         <pc:sldMkLst>
           <pc:docMk/>
           <pc:sldMk cId="406580661" sldId="286"/>
         </pc:sldMkLst>
-        <pc:spChg chg="mod">
-          <ac:chgData name="Jean-Yves Vuillequez" userId="e7fac481abea6bd0" providerId="LiveId" clId="{79E365E8-22BC-4EC2-9606-9A9AC6CD1D22}" dt="2025-11-19T10:59:01.978" v="55" actId="20577"/>
+        <pc:spChg chg="add del mod">
+          <ac:chgData name="Jean-Yves Vuillequez" userId="e7fac481abea6bd0" providerId="LiveId" clId="{79E365E8-22BC-4EC2-9606-9A9AC6CD1D22}" dt="2025-11-19T15:04:10.897" v="143" actId="478"/>
+          <ac:spMkLst>
+            <pc:docMk/>
+            <pc:sldMk cId="406580661" sldId="286"/>
+            <ac:spMk id="3" creationId="{C43968D4-0691-98E3-02E7-DB654E7392F3}"/>
+          </ac:spMkLst>
+        </pc:spChg>
+        <pc:spChg chg="add mod">
+          <ac:chgData name="Jean-Yves Vuillequez" userId="e7fac481abea6bd0" providerId="LiveId" clId="{79E365E8-22BC-4EC2-9606-9A9AC6CD1D22}" dt="2025-11-19T15:04:11.263" v="144"/>
+          <ac:spMkLst>
+            <pc:docMk/>
+            <pc:sldMk cId="406580661" sldId="286"/>
+            <ac:spMk id="4" creationId="{0649B650-4A2A-7387-5E59-6EEF0B39EF13}"/>
+          </ac:spMkLst>
+        </pc:spChg>
+        <pc:spChg chg="del">
+          <ac:chgData name="Jean-Yves Vuillequez" userId="e7fac481abea6bd0" providerId="LiveId" clId="{79E365E8-22BC-4EC2-9606-9A9AC6CD1D22}" dt="2025-11-19T15:03:54.191" v="140" actId="478"/>
+          <ac:spMkLst>
+            <pc:docMk/>
+            <pc:sldMk cId="406580661" sldId="286"/>
+            <ac:spMk id="69" creationId="{2DFE67F9-5520-F4B8-B6C5-40C9605525B6}"/>
+          </ac:spMkLst>
+        </pc:spChg>
+        <pc:spChg chg="del mod">
+          <ac:chgData name="Jean-Yves Vuillequez" userId="e7fac481abea6bd0" providerId="LiveId" clId="{79E365E8-22BC-4EC2-9606-9A9AC6CD1D22}" dt="2025-11-19T15:04:08.497" v="142" actId="478"/>
           <ac:spMkLst>
             <pc:docMk/>
             <pc:sldMk cId="406580661" sldId="286"/>
             <ac:spMk id="73" creationId="{1362DE8B-B008-E6AB-C9CD-6095A12B8D39}"/>
           </ac:spMkLst>
         </pc:spChg>
-        <pc:spChg chg="mod">
-          <ac:chgData name="Jean-Yves Vuillequez" userId="e7fac481abea6bd0" providerId="LiveId" clId="{79E365E8-22BC-4EC2-9606-9A9AC6CD1D22}" dt="2025-11-19T10:59:24.012" v="72" actId="1076"/>
+        <pc:spChg chg="del mod">
+          <ac:chgData name="Jean-Yves Vuillequez" userId="e7fac481abea6bd0" providerId="LiveId" clId="{79E365E8-22BC-4EC2-9606-9A9AC6CD1D22}" dt="2025-11-19T15:03:54.191" v="140" actId="478"/>
           <ac:spMkLst>
             <pc:docMk/>
             <pc:sldMk cId="406580661" sldId="286"/>
             <ac:spMk id="74" creationId="{594EF5A4-95A8-DB9E-307C-92C5044EEF3F}"/>
           </ac:spMkLst>
         </pc:spChg>
-        <pc:spChg chg="mod">
-          <ac:chgData name="Jean-Yves Vuillequez" userId="e7fac481abea6bd0" providerId="LiveId" clId="{79E365E8-22BC-4EC2-9606-9A9AC6CD1D22}" dt="2025-11-19T10:59:24.012" v="72" actId="1076"/>
+        <pc:spChg chg="del mod">
+          <ac:chgData name="Jean-Yves Vuillequez" userId="e7fac481abea6bd0" providerId="LiveId" clId="{79E365E8-22BC-4EC2-9606-9A9AC6CD1D22}" dt="2025-11-19T15:03:57.484" v="141" actId="478"/>
           <ac:spMkLst>
             <pc:docMk/>
             <pc:sldMk cId="406580661" sldId="286"/>
             <ac:spMk id="75" creationId="{2DA76B5D-5507-C433-3A50-BA24AFDD5759}"/>
           </ac:spMkLst>
         </pc:spChg>
-        <pc:spChg chg="mod">
-          <ac:chgData name="Jean-Yves Vuillequez" userId="e7fac481abea6bd0" providerId="LiveId" clId="{79E365E8-22BC-4EC2-9606-9A9AC6CD1D22}" dt="2025-11-19T10:59:24.012" v="72" actId="1076"/>
+        <pc:spChg chg="del mod">
+          <ac:chgData name="Jean-Yves Vuillequez" userId="e7fac481abea6bd0" providerId="LiveId" clId="{79E365E8-22BC-4EC2-9606-9A9AC6CD1D22}" dt="2025-11-19T15:03:57.484" v="141" actId="478"/>
           <ac:spMkLst>
             <pc:docMk/>
             <pc:sldMk cId="406580661" sldId="286"/>
             <ac:spMk id="76" creationId="{0D0BEA13-407D-BB40-EDD4-89543044A7D8}"/>
           </ac:spMkLst>
         </pc:spChg>
-        <pc:spChg chg="mod">
-          <ac:chgData name="Jean-Yves Vuillequez" userId="e7fac481abea6bd0" providerId="LiveId" clId="{79E365E8-22BC-4EC2-9606-9A9AC6CD1D22}" dt="2025-11-19T10:59:24.012" v="72" actId="1076"/>
+        <pc:spChg chg="del mod">
+          <ac:chgData name="Jean-Yves Vuillequez" userId="e7fac481abea6bd0" providerId="LiveId" clId="{79E365E8-22BC-4EC2-9606-9A9AC6CD1D22}" dt="2025-11-19T15:03:57.484" v="141" actId="478"/>
           <ac:spMkLst>
             <pc:docMk/>
             <pc:sldMk cId="406580661" sldId="286"/>
@@ -1517,7 +1651,7 @@
               <a:buSzPts val="1100"/>
               <a:buNone/>
             </a:pPr>
-            <a:endParaRPr/>
+            <a:endParaRPr dirty="0"/>
           </a:p>
         </p:txBody>
       </p:sp>
@@ -1539,10 +1673,10 @@
   <p:cSld>
     <p:spTree>
       <p:nvGrpSpPr>
-        <p:cNvPr id="1" name="Shape 58">
+        <p:cNvPr id="1" name="Shape 92">
           <a:extLst>
             <a:ext uri="{FF2B5EF4-FFF2-40B4-BE49-F238E27FC236}">
-              <a16:creationId xmlns:a16="http://schemas.microsoft.com/office/drawing/2014/main" id="{5FD8F731-0B60-9E58-BF85-C6F39AAA128F}"/>
+              <a16:creationId xmlns:a16="http://schemas.microsoft.com/office/drawing/2014/main" id="{601F1211-8719-8070-13C6-DFAABBD5A0A6}"/>
             </a:ext>
           </a:extLst>
         </p:cNvPr>
@@ -1559,10 +1693,10 @@
       </p:grpSpPr>
       <p:sp>
         <p:nvSpPr>
-          <p:cNvPr id="59" name="Google Shape;59;g3bc3b886ea_0_1:notes">
+          <p:cNvPr id="93" name="Google Shape;93;p5:notes">
             <a:extLst>
               <a:ext uri="{FF2B5EF4-FFF2-40B4-BE49-F238E27FC236}">
-                <a16:creationId xmlns:a16="http://schemas.microsoft.com/office/drawing/2014/main" id="{3CEB66D1-BECD-566A-52EE-E59E3C893DFC}"/>
+                <a16:creationId xmlns:a16="http://schemas.microsoft.com/office/drawing/2014/main" id="{24E1F0BF-E30D-AAB8-17C4-1E198C29A80F}"/>
               </a:ext>
             </a:extLst>
           </p:cNvPr>
@@ -1602,14 +1736,24 @@
               </a:path>
             </a:pathLst>
           </a:custGeom>
+          <a:noFill/>
+          <a:ln w="9525" cap="flat" cmpd="sng">
+            <a:solidFill>
+              <a:srgbClr val="000000"/>
+            </a:solidFill>
+            <a:prstDash val="solid"/>
+            <a:round/>
+            <a:headEnd type="none" w="sm" len="sm"/>
+            <a:tailEnd type="none" w="sm" len="sm"/>
+          </a:ln>
         </p:spPr>
       </p:sp>
       <p:sp>
         <p:nvSpPr>
-          <p:cNvPr id="60" name="Google Shape;60;g3bc3b886ea_0_1:notes">
+          <p:cNvPr id="94" name="Google Shape;94;p5:notes">
             <a:extLst>
               <a:ext uri="{FF2B5EF4-FFF2-40B4-BE49-F238E27FC236}">
-                <a16:creationId xmlns:a16="http://schemas.microsoft.com/office/drawing/2014/main" id="{BD88C69A-BD09-8A38-E0BB-3A883E1BF525}"/>
+                <a16:creationId xmlns:a16="http://schemas.microsoft.com/office/drawing/2014/main" id="{FAE7E81C-5300-A69F-6961-16DCBFE11F25}"/>
               </a:ext>
             </a:extLst>
           </p:cNvPr>
@@ -1628,6 +1772,10 @@
           <a:prstGeom prst="rect">
             <a:avLst/>
           </a:prstGeom>
+          <a:noFill/>
+          <a:ln>
+            <a:noFill/>
+          </a:ln>
         </p:spPr>
         <p:txBody>
           <a:bodyPr spcFirstLastPara="1" wrap="square" lIns="91425" tIns="91425" rIns="91425" bIns="91425" anchor="t" anchorCtr="0">
@@ -1635,23 +1783,162 @@
           </a:bodyPr>
           <a:lstStyle/>
           <a:p>
+            <a:r>
+              <a:rPr lang="fr-FR" b="1" dirty="0"/>
+              <a:t>Collecte des données</a:t>
+            </a:r>
+          </a:p>
+          <a:p>
+            <a:r>
+              <a:rPr lang="fr-FR" dirty="0"/>
+              <a:t>Données météo </a:t>
+            </a:r>
+            <a:r>
+              <a:rPr lang="fr-FR" dirty="0" err="1"/>
+              <a:t>OpenWeather</a:t>
+            </a:r>
+            <a:r>
+              <a:rPr lang="fr-FR" dirty="0"/>
+              <a:t> (API)</a:t>
+            </a:r>
+          </a:p>
+          <a:p>
+            <a:r>
+              <a:rPr lang="fr-FR" dirty="0"/>
+              <a:t>Données satellite Landsat (USGS)</a:t>
+            </a:r>
+          </a:p>
+          <a:p>
+            <a:r>
+              <a:rPr lang="fr-FR" dirty="0"/>
+              <a:t>Historique RTE</a:t>
+            </a:r>
+          </a:p>
+          <a:p>
+            <a:r>
+              <a:rPr lang="fr-FR" dirty="0"/>
+              <a:t>Données solaires locales</a:t>
+            </a:r>
+          </a:p>
+          <a:p>
+            <a:r>
+              <a:rPr lang="fr-FR" b="1" dirty="0"/>
+              <a:t>2. Préparation &amp; nettoyage</a:t>
+            </a:r>
+          </a:p>
+          <a:p>
+            <a:r>
+              <a:rPr lang="fr-FR" dirty="0"/>
+              <a:t>Standardisation</a:t>
+            </a:r>
+          </a:p>
+          <a:p>
+            <a:r>
+              <a:rPr lang="fr-FR" dirty="0"/>
+              <a:t>Alignement temporel</a:t>
+            </a:r>
+          </a:p>
+          <a:p>
+            <a:r>
+              <a:rPr lang="fr-FR" dirty="0"/>
+              <a:t>Filtrage géographique Rhône-Alpes</a:t>
+            </a:r>
+          </a:p>
+          <a:p>
+            <a:r>
+              <a:rPr lang="fr-FR" dirty="0"/>
+              <a:t>Mise en qualité</a:t>
+            </a:r>
+          </a:p>
+          <a:p>
+            <a:r>
+              <a:rPr lang="fr-FR" b="1" dirty="0"/>
+              <a:t>3. Entraînement &amp; suivi du modèle</a:t>
+            </a:r>
+          </a:p>
+          <a:p>
+            <a:r>
+              <a:rPr lang="fr-FR" dirty="0"/>
+              <a:t>Entraînement local</a:t>
+            </a:r>
+          </a:p>
+          <a:p>
+            <a:r>
+              <a:rPr lang="fr-FR" dirty="0"/>
+              <a:t>Suivi via </a:t>
+            </a:r>
+            <a:r>
+              <a:rPr lang="fr-FR" dirty="0" err="1"/>
+              <a:t>MLflow</a:t>
+            </a:r>
+            <a:endParaRPr lang="fr-FR" dirty="0"/>
+          </a:p>
+          <a:p>
+            <a:r>
+              <a:rPr lang="fr-FR" dirty="0" err="1"/>
+              <a:t>Versionning</a:t>
+            </a:r>
+            <a:r>
+              <a:rPr lang="fr-FR" dirty="0"/>
+              <a:t> dans Model </a:t>
+            </a:r>
+            <a:r>
+              <a:rPr lang="fr-FR" dirty="0" err="1"/>
+              <a:t>Registry</a:t>
+            </a:r>
+            <a:endParaRPr lang="fr-FR" dirty="0"/>
+          </a:p>
+          <a:p>
+            <a:r>
+              <a:rPr lang="fr-FR" b="1" dirty="0"/>
+              <a:t>4. API &amp; Application</a:t>
+            </a:r>
+          </a:p>
+          <a:p>
+            <a:r>
+              <a:rPr lang="fr-FR" dirty="0"/>
+              <a:t>Modèle servi via une API</a:t>
+            </a:r>
+          </a:p>
+          <a:p>
+            <a:r>
+              <a:rPr lang="fr-FR" dirty="0"/>
+              <a:t>Dashboard </a:t>
+            </a:r>
+            <a:r>
+              <a:rPr lang="fr-FR" dirty="0" err="1"/>
+              <a:t>Streamlit</a:t>
+            </a:r>
+            <a:endParaRPr lang="fr-FR" dirty="0"/>
+          </a:p>
+          <a:p>
+            <a:r>
+              <a:rPr lang="fr-FR" dirty="0"/>
+              <a:t>EDA + prévisions 7 jours accessibles à l’utilisateur</a:t>
+            </a:r>
+          </a:p>
+          <a:p>
             <a:pPr marL="0" lvl="0" indent="0" algn="l" rtl="0">
-              <a:spcBef>
-                <a:spcPts val="0"/>
-              </a:spcBef>
-              <a:spcAft>
-                <a:spcPts val="0"/>
-              </a:spcAft>
+              <a:lnSpc>
+                <a:spcPct val="100000"/>
+              </a:lnSpc>
+              <a:spcBef>
+                <a:spcPts val="0"/>
+              </a:spcBef>
+              <a:spcAft>
+                <a:spcPts val="0"/>
+              </a:spcAft>
+              <a:buSzPts val="1100"/>
               <a:buNone/>
             </a:pPr>
-            <a:endParaRPr/>
+            <a:endParaRPr dirty="0"/>
           </a:p>
         </p:txBody>
       </p:sp>
     </p:spTree>
     <p:extLst>
       <p:ext uri="{BB962C8B-B14F-4D97-AF65-F5344CB8AC3E}">
-        <p14:creationId xmlns:p14="http://schemas.microsoft.com/office/powerpoint/2010/main" val="3461525251"/>
+        <p14:creationId xmlns:p14="http://schemas.microsoft.com/office/powerpoint/2010/main" val="1960619631"/>
       </p:ext>
     </p:extLst>
   </p:cSld>
@@ -1899,7 +2186,7 @@
     </p:spTree>
     <p:extLst>
       <p:ext uri="{BB962C8B-B14F-4D97-AF65-F5344CB8AC3E}">
-        <p14:creationId xmlns:p14="http://schemas.microsoft.com/office/powerpoint/2010/main" val="1623490249"/>
+        <p14:creationId xmlns:p14="http://schemas.microsoft.com/office/powerpoint/2010/main" val="2693613996"/>
       </p:ext>
     </p:extLst>
   </p:cSld>
@@ -1910,151 +2197,6 @@
 </file>
 
 <file path=ppt/notesSlides/notesSlide7.xml><?xml version="1.0" encoding="utf-8"?>
-<p:notes xmlns:a="http://schemas.openxmlformats.org/drawingml/2006/main" xmlns:r="http://schemas.openxmlformats.org/officeDocument/2006/relationships" xmlns:p="http://schemas.openxmlformats.org/presentationml/2006/main" showMasterSp="0" showMasterPhAnim="0">
-  <p:cSld>
-    <p:spTree>
-      <p:nvGrpSpPr>
-        <p:cNvPr id="1" name="Shape 92">
-          <a:extLst>
-            <a:ext uri="{FF2B5EF4-FFF2-40B4-BE49-F238E27FC236}">
-              <a16:creationId xmlns:a16="http://schemas.microsoft.com/office/drawing/2014/main" id="{601F1211-8719-8070-13C6-DFAABBD5A0A6}"/>
-            </a:ext>
-          </a:extLst>
-        </p:cNvPr>
-        <p:cNvGrpSpPr/>
-        <p:nvPr/>
-      </p:nvGrpSpPr>
-      <p:grpSpPr>
-        <a:xfrm>
-          <a:off x="0" y="0"/>
-          <a:ext cx="0" cy="0"/>
-          <a:chOff x="0" y="0"/>
-          <a:chExt cx="0" cy="0"/>
-        </a:xfrm>
-      </p:grpSpPr>
-      <p:sp>
-        <p:nvSpPr>
-          <p:cNvPr id="93" name="Google Shape;93;p5:notes">
-            <a:extLst>
-              <a:ext uri="{FF2B5EF4-FFF2-40B4-BE49-F238E27FC236}">
-                <a16:creationId xmlns:a16="http://schemas.microsoft.com/office/drawing/2014/main" id="{24E1F0BF-E30D-AAB8-17C4-1E198C29A80F}"/>
-              </a:ext>
-            </a:extLst>
-          </p:cNvPr>
-          <p:cNvSpPr>
-            <a:spLocks noGrp="1" noRot="1" noChangeAspect="1"/>
-          </p:cNvSpPr>
-          <p:nvPr>
-            <p:ph type="sldImg" idx="2"/>
-          </p:nvPr>
-        </p:nvSpPr>
-        <p:spPr>
-          <a:xfrm>
-            <a:off x="381000" y="685800"/>
-            <a:ext cx="6096000" cy="3429000"/>
-          </a:xfrm>
-          <a:custGeom>
-            <a:avLst/>
-            <a:gdLst/>
-            <a:ahLst/>
-            <a:cxnLst/>
-            <a:rect l="l" t="t" r="r" b="b"/>
-            <a:pathLst>
-              <a:path w="120000" h="120000" extrusionOk="0">
-                <a:moveTo>
-                  <a:pt x="0" y="0"/>
-                </a:moveTo>
-                <a:lnTo>
-                  <a:pt x="120000" y="0"/>
-                </a:lnTo>
-                <a:lnTo>
-                  <a:pt x="120000" y="120000"/>
-                </a:lnTo>
-                <a:lnTo>
-                  <a:pt x="0" y="120000"/>
-                </a:lnTo>
-                <a:close/>
-              </a:path>
-            </a:pathLst>
-          </a:custGeom>
-          <a:noFill/>
-          <a:ln w="9525" cap="flat" cmpd="sng">
-            <a:solidFill>
-              <a:srgbClr val="000000"/>
-            </a:solidFill>
-            <a:prstDash val="solid"/>
-            <a:round/>
-            <a:headEnd type="none" w="sm" len="sm"/>
-            <a:tailEnd type="none" w="sm" len="sm"/>
-          </a:ln>
-        </p:spPr>
-      </p:sp>
-      <p:sp>
-        <p:nvSpPr>
-          <p:cNvPr id="94" name="Google Shape;94;p5:notes">
-            <a:extLst>
-              <a:ext uri="{FF2B5EF4-FFF2-40B4-BE49-F238E27FC236}">
-                <a16:creationId xmlns:a16="http://schemas.microsoft.com/office/drawing/2014/main" id="{FAE7E81C-5300-A69F-6961-16DCBFE11F25}"/>
-              </a:ext>
-            </a:extLst>
-          </p:cNvPr>
-          <p:cNvSpPr txBox="1">
-            <a:spLocks noGrp="1"/>
-          </p:cNvSpPr>
-          <p:nvPr>
-            <p:ph type="body" idx="1"/>
-          </p:nvPr>
-        </p:nvSpPr>
-        <p:spPr>
-          <a:xfrm>
-            <a:off x="685800" y="4343400"/>
-            <a:ext cx="5486400" cy="4114800"/>
-          </a:xfrm>
-          <a:prstGeom prst="rect">
-            <a:avLst/>
-          </a:prstGeom>
-          <a:noFill/>
-          <a:ln>
-            <a:noFill/>
-          </a:ln>
-        </p:spPr>
-        <p:txBody>
-          <a:bodyPr spcFirstLastPara="1" wrap="square" lIns="91425" tIns="91425" rIns="91425" bIns="91425" anchor="t" anchorCtr="0">
-            <a:noAutofit/>
-          </a:bodyPr>
-          <a:lstStyle/>
-          <a:p>
-            <a:pPr marL="0" lvl="0" indent="0" algn="l" rtl="0">
-              <a:lnSpc>
-                <a:spcPct val="100000"/>
-              </a:lnSpc>
-              <a:spcBef>
-                <a:spcPts val="0"/>
-              </a:spcBef>
-              <a:spcAft>
-                <a:spcPts val="0"/>
-              </a:spcAft>
-              <a:buSzPts val="1100"/>
-              <a:buNone/>
-            </a:pPr>
-            <a:endParaRPr/>
-          </a:p>
-        </p:txBody>
-      </p:sp>
-    </p:spTree>
-    <p:extLst>
-      <p:ext uri="{BB962C8B-B14F-4D97-AF65-F5344CB8AC3E}">
-        <p14:creationId xmlns:p14="http://schemas.microsoft.com/office/powerpoint/2010/main" val="1960619631"/>
-      </p:ext>
-    </p:extLst>
-  </p:cSld>
-  <p:clrMapOvr>
-    <a:masterClrMapping/>
-  </p:clrMapOvr>
-</p:notes>
-</file>
-
-<file path=ppt/notesSlides/notesSlide8.xml><?xml version="1.0" encoding="utf-8"?>
 <p:notes xmlns:a="http://schemas.openxmlformats.org/drawingml/2006/main" xmlns:r="http://schemas.openxmlformats.org/officeDocument/2006/relationships" xmlns:p="http://schemas.openxmlformats.org/presentationml/2006/main" showMasterSp="0" showMasterPhAnim="0">
   <p:cSld>
     <p:spTree>
@@ -2199,7 +2341,7 @@
 </p:notes>
 </file>
 
-<file path=ppt/notesSlides/notesSlide9.xml><?xml version="1.0" encoding="utf-8"?>
+<file path=ppt/notesSlides/notesSlide8.xml><?xml version="1.0" encoding="utf-8"?>
 <p:notes xmlns:a="http://schemas.openxmlformats.org/drawingml/2006/main" xmlns:r="http://schemas.openxmlformats.org/officeDocument/2006/relationships" xmlns:p="http://schemas.openxmlformats.org/presentationml/2006/main" showMasterSp="0" showMasterPhAnim="0">
   <p:cSld>
     <p:spTree>
@@ -15434,68 +15576,6 @@
       </p:grpSpPr>
       <p:sp>
         <p:nvSpPr>
-          <p:cNvPr id="69" name="Google Shape;69;p3">
-            <a:extLst>
-              <a:ext uri="{FF2B5EF4-FFF2-40B4-BE49-F238E27FC236}">
-                <a16:creationId xmlns:a16="http://schemas.microsoft.com/office/drawing/2014/main" id="{2DFE67F9-5520-F4B8-B6C5-40C9605525B6}"/>
-              </a:ext>
-            </a:extLst>
-          </p:cNvPr>
-          <p:cNvSpPr/>
-          <p:nvPr/>
-        </p:nvSpPr>
-        <p:spPr>
-          <a:xfrm>
-            <a:off x="311700" y="920082"/>
-            <a:ext cx="8399163" cy="939281"/>
-          </a:xfrm>
-          <a:prstGeom prst="rect">
-            <a:avLst/>
-          </a:prstGeom>
-          <a:solidFill>
-            <a:srgbClr val="3FDAD2"/>
-          </a:solidFill>
-          <a:ln>
-            <a:noFill/>
-          </a:ln>
-        </p:spPr>
-        <p:txBody>
-          <a:bodyPr spcFirstLastPara="1" wrap="square" lIns="91425" tIns="45700" rIns="91425" bIns="45700" anchor="ctr" anchorCtr="0">
-            <a:noAutofit/>
-          </a:bodyPr>
-          <a:lstStyle/>
-          <a:p>
-            <a:pPr marL="0" marR="0" lvl="0" indent="0" algn="ctr" rtl="0">
-              <a:lnSpc>
-                <a:spcPct val="100000"/>
-              </a:lnSpc>
-              <a:spcBef>
-                <a:spcPts val="0"/>
-              </a:spcBef>
-              <a:spcAft>
-                <a:spcPts val="0"/>
-              </a:spcAft>
-              <a:buClr>
-                <a:srgbClr val="000000"/>
-              </a:buClr>
-              <a:buSzPts val="1400"/>
-              <a:buFont typeface="Arial"/>
-              <a:buNone/>
-            </a:pPr>
-            <a:endParaRPr sz="1400" b="0" i="0" u="none" strike="noStrike" cap="none">
-              <a:solidFill>
-                <a:schemeClr val="lt1"/>
-              </a:solidFill>
-              <a:latin typeface="Arial"/>
-              <a:ea typeface="Arial"/>
-              <a:cs typeface="Arial"/>
-              <a:sym typeface="Arial"/>
-            </a:endParaRPr>
-          </a:p>
-        </p:txBody>
-      </p:sp>
-      <p:sp>
-        <p:nvSpPr>
           <p:cNvPr id="70" name="Google Shape;70;p3">
             <a:extLst>
               <a:ext uri="{FF2B5EF4-FFF2-40B4-BE49-F238E27FC236}">
@@ -15547,7 +15627,7 @@
               <a:buNone/>
             </a:pPr>
             <a:r>
-              <a:rPr lang="fr" sz="2500" b="1" i="0" u="none" strike="noStrike" cap="none">
+              <a:rPr lang="fr" sz="2500" b="1" i="0" u="none" strike="noStrike" cap="none" dirty="0">
                 <a:solidFill>
                   <a:srgbClr val="0E3449"/>
                 </a:solidFill>
@@ -15558,7 +15638,7 @@
               </a:rPr>
               <a:t>Pitch</a:t>
             </a:r>
-            <a:endParaRPr sz="2500" b="1" i="0" u="none" strike="noStrike" cap="none">
+            <a:endParaRPr sz="2500" b="1" i="0" u="none" strike="noStrike" cap="none" dirty="0">
               <a:solidFill>
                 <a:srgbClr val="0E3449"/>
               </a:solidFill>
@@ -15667,904 +15747,13 @@
       </p:pic>
       <p:sp>
         <p:nvSpPr>
-          <p:cNvPr id="73" name="Google Shape;73;p3">
+          <p:cNvPr id="4" name="Google Shape;181;p8">
             <a:extLst>
               <a:ext uri="{FF2B5EF4-FFF2-40B4-BE49-F238E27FC236}">
-                <a16:creationId xmlns:a16="http://schemas.microsoft.com/office/drawing/2014/main" id="{1362DE8B-B008-E6AB-C9CD-6095A12B8D39}"/>
+                <a16:creationId xmlns:a16="http://schemas.microsoft.com/office/drawing/2014/main" id="{0649B650-4A2A-7387-5E59-6EEF0B39EF13}"/>
               </a:ext>
             </a:extLst>
           </p:cNvPr>
-          <p:cNvSpPr txBox="1">
-            <a:spLocks noGrp="1"/>
-          </p:cNvSpPr>
-          <p:nvPr>
-            <p:ph type="body" idx="1"/>
-          </p:nvPr>
-        </p:nvSpPr>
-        <p:spPr>
-          <a:xfrm>
-            <a:off x="311700" y="914104"/>
-            <a:ext cx="8520600" cy="989387"/>
-          </a:xfrm>
-          <a:prstGeom prst="rect">
-            <a:avLst/>
-          </a:prstGeom>
-          <a:noFill/>
-          <a:ln>
-            <a:noFill/>
-          </a:ln>
-        </p:spPr>
-        <p:txBody>
-          <a:bodyPr spcFirstLastPara="1" wrap="square" lIns="91425" tIns="91425" rIns="91425" bIns="91425" anchor="t" anchorCtr="0">
-            <a:noAutofit/>
-          </a:bodyPr>
-          <a:lstStyle/>
-          <a:p>
-            <a:pPr marL="114300" lvl="0" indent="0" algn="l" rtl="0">
-              <a:lnSpc>
-                <a:spcPct val="115000"/>
-              </a:lnSpc>
-              <a:spcBef>
-                <a:spcPts val="0"/>
-              </a:spcBef>
-              <a:spcAft>
-                <a:spcPts val="0"/>
-              </a:spcAft>
-              <a:buSzPts val="1800"/>
-              <a:buNone/>
-            </a:pPr>
-            <a:r>
-              <a:rPr lang="fr-FR" sz="1100" dirty="0" err="1">
-                <a:solidFill>
-                  <a:srgbClr val="41545E"/>
-                </a:solidFill>
-              </a:rPr>
-              <a:t>xxxxx</a:t>
-            </a:r>
-            <a:endParaRPr lang="fr-FR" sz="1100" b="1" dirty="0">
-              <a:solidFill>
-                <a:srgbClr val="41545E"/>
-              </a:solidFill>
-            </a:endParaRPr>
-          </a:p>
-        </p:txBody>
-      </p:sp>
-      <p:sp>
-        <p:nvSpPr>
-          <p:cNvPr id="74" name="Google Shape;74;p3">
-            <a:extLst>
-              <a:ext uri="{FF2B5EF4-FFF2-40B4-BE49-F238E27FC236}">
-                <a16:creationId xmlns:a16="http://schemas.microsoft.com/office/drawing/2014/main" id="{594EF5A4-95A8-DB9E-307C-92C5044EEF3F}"/>
-              </a:ext>
-            </a:extLst>
-          </p:cNvPr>
-          <p:cNvSpPr/>
-          <p:nvPr/>
-        </p:nvSpPr>
-        <p:spPr>
-          <a:xfrm>
-            <a:off x="3361455" y="2527339"/>
-            <a:ext cx="2102852" cy="1812804"/>
-          </a:xfrm>
-          <a:prstGeom prst="triangle">
-            <a:avLst>
-              <a:gd name="adj" fmla="val 50000"/>
-            </a:avLst>
-          </a:prstGeom>
-          <a:solidFill>
-            <a:srgbClr val="3FDAD2"/>
-          </a:solidFill>
-          <a:ln>
-            <a:noFill/>
-          </a:ln>
-        </p:spPr>
-        <p:txBody>
-          <a:bodyPr spcFirstLastPara="1" wrap="square" lIns="91425" tIns="45700" rIns="91425" bIns="45700" anchor="ctr" anchorCtr="0">
-            <a:noAutofit/>
-          </a:bodyPr>
-          <a:lstStyle/>
-          <a:p>
-            <a:pPr marL="0" marR="0" lvl="0" indent="0" algn="ctr" rtl="0">
-              <a:lnSpc>
-                <a:spcPct val="100000"/>
-              </a:lnSpc>
-              <a:spcBef>
-                <a:spcPts val="0"/>
-              </a:spcBef>
-              <a:spcAft>
-                <a:spcPts val="0"/>
-              </a:spcAft>
-              <a:buClr>
-                <a:srgbClr val="000000"/>
-              </a:buClr>
-              <a:buSzPts val="1400"/>
-              <a:buFont typeface="Arial"/>
-              <a:buNone/>
-            </a:pPr>
-            <a:endParaRPr sz="1400" b="0" i="0" u="none" strike="noStrike" cap="none">
-              <a:solidFill>
-                <a:schemeClr val="lt1"/>
-              </a:solidFill>
-              <a:latin typeface="Arial"/>
-              <a:ea typeface="Arial"/>
-              <a:cs typeface="Arial"/>
-              <a:sym typeface="Arial"/>
-            </a:endParaRPr>
-          </a:p>
-        </p:txBody>
-      </p:sp>
-      <p:sp>
-        <p:nvSpPr>
-          <p:cNvPr id="75" name="Google Shape;75;p3">
-            <a:extLst>
-              <a:ext uri="{FF2B5EF4-FFF2-40B4-BE49-F238E27FC236}">
-                <a16:creationId xmlns:a16="http://schemas.microsoft.com/office/drawing/2014/main" id="{2DA76B5D-5507-C433-3A50-BA24AFDD5759}"/>
-              </a:ext>
-            </a:extLst>
-          </p:cNvPr>
-          <p:cNvSpPr txBox="1"/>
-          <p:nvPr/>
-        </p:nvSpPr>
-        <p:spPr>
-          <a:xfrm>
-            <a:off x="3071360" y="2046717"/>
-            <a:ext cx="2683042" cy="307736"/>
-          </a:xfrm>
-          <a:prstGeom prst="rect">
-            <a:avLst/>
-          </a:prstGeom>
-          <a:noFill/>
-          <a:ln>
-            <a:noFill/>
-          </a:ln>
-        </p:spPr>
-        <p:txBody>
-          <a:bodyPr spcFirstLastPara="1" wrap="square" lIns="91425" tIns="45700" rIns="91425" bIns="45700" anchor="t" anchorCtr="0">
-            <a:spAutoFit/>
-          </a:bodyPr>
-          <a:lstStyle/>
-          <a:p>
-            <a:pPr marL="0" marR="0" lvl="0" indent="0" algn="ctr" rtl="0">
-              <a:lnSpc>
-                <a:spcPct val="100000"/>
-              </a:lnSpc>
-              <a:spcBef>
-                <a:spcPts val="0"/>
-              </a:spcBef>
-              <a:spcAft>
-                <a:spcPts val="0"/>
-              </a:spcAft>
-              <a:buClr>
-                <a:srgbClr val="000000"/>
-              </a:buClr>
-              <a:buSzPts val="1400"/>
-              <a:buFont typeface="Arial"/>
-              <a:buNone/>
-            </a:pPr>
-            <a:r>
-              <a:rPr lang="fr-FR" sz="1400" b="1" i="0" u="none" strike="noStrike" cap="none" dirty="0" err="1">
-                <a:solidFill>
-                  <a:srgbClr val="41545E"/>
-                </a:solidFill>
-                <a:latin typeface="Arial"/>
-                <a:ea typeface="Arial"/>
-                <a:cs typeface="Arial"/>
-                <a:sym typeface="Arial"/>
-              </a:rPr>
-              <a:t>xxxx</a:t>
-            </a:r>
-            <a:endParaRPr sz="1400" b="1" i="0" u="none" strike="noStrike" cap="none" dirty="0">
-              <a:solidFill>
-                <a:srgbClr val="41545E"/>
-              </a:solidFill>
-              <a:latin typeface="Arial"/>
-              <a:ea typeface="Arial"/>
-              <a:cs typeface="Arial"/>
-              <a:sym typeface="Arial"/>
-            </a:endParaRPr>
-          </a:p>
-        </p:txBody>
-      </p:sp>
-      <p:sp>
-        <p:nvSpPr>
-          <p:cNvPr id="76" name="Google Shape;76;p3">
-            <a:extLst>
-              <a:ext uri="{FF2B5EF4-FFF2-40B4-BE49-F238E27FC236}">
-                <a16:creationId xmlns:a16="http://schemas.microsoft.com/office/drawing/2014/main" id="{0D0BEA13-407D-BB40-EDD4-89543044A7D8}"/>
-              </a:ext>
-            </a:extLst>
-          </p:cNvPr>
-          <p:cNvSpPr txBox="1"/>
-          <p:nvPr/>
-        </p:nvSpPr>
-        <p:spPr>
-          <a:xfrm>
-            <a:off x="4310613" y="4416423"/>
-            <a:ext cx="2683042" cy="307736"/>
-          </a:xfrm>
-          <a:prstGeom prst="rect">
-            <a:avLst/>
-          </a:prstGeom>
-          <a:noFill/>
-          <a:ln>
-            <a:noFill/>
-          </a:ln>
-        </p:spPr>
-        <p:txBody>
-          <a:bodyPr spcFirstLastPara="1" wrap="square" lIns="91425" tIns="45700" rIns="91425" bIns="45700" anchor="t" anchorCtr="0">
-            <a:spAutoFit/>
-          </a:bodyPr>
-          <a:lstStyle/>
-          <a:p>
-            <a:pPr marL="0" marR="0" lvl="0" indent="0" algn="ctr" rtl="0">
-              <a:lnSpc>
-                <a:spcPct val="100000"/>
-              </a:lnSpc>
-              <a:spcBef>
-                <a:spcPts val="0"/>
-              </a:spcBef>
-              <a:spcAft>
-                <a:spcPts val="0"/>
-              </a:spcAft>
-              <a:buClr>
-                <a:srgbClr val="000000"/>
-              </a:buClr>
-              <a:buSzPts val="1400"/>
-              <a:buFont typeface="Arial"/>
-              <a:buNone/>
-            </a:pPr>
-            <a:r>
-              <a:rPr lang="fr-FR" sz="1400" b="1" i="0" u="none" strike="noStrike" cap="none" dirty="0">
-                <a:solidFill>
-                  <a:srgbClr val="41545E"/>
-                </a:solidFill>
-                <a:latin typeface="Arial"/>
-                <a:ea typeface="Arial"/>
-                <a:cs typeface="Arial"/>
-                <a:sym typeface="Arial"/>
-              </a:rPr>
-              <a:t>xxx</a:t>
-            </a:r>
-            <a:endParaRPr sz="1400" b="0" i="0" u="none" strike="noStrike" cap="none" dirty="0">
-              <a:solidFill>
-                <a:srgbClr val="41545E"/>
-              </a:solidFill>
-              <a:latin typeface="Arial"/>
-              <a:ea typeface="Arial"/>
-              <a:cs typeface="Arial"/>
-              <a:sym typeface="Arial"/>
-            </a:endParaRPr>
-          </a:p>
-        </p:txBody>
-      </p:sp>
-      <p:sp>
-        <p:nvSpPr>
-          <p:cNvPr id="77" name="Google Shape;77;p3">
-            <a:extLst>
-              <a:ext uri="{FF2B5EF4-FFF2-40B4-BE49-F238E27FC236}">
-                <a16:creationId xmlns:a16="http://schemas.microsoft.com/office/drawing/2014/main" id="{4B2D55FD-E6CB-F70B-1A6D-C59E9EAB43E2}"/>
-              </a:ext>
-            </a:extLst>
-          </p:cNvPr>
-          <p:cNvSpPr txBox="1"/>
-          <p:nvPr/>
-        </p:nvSpPr>
-        <p:spPr>
-          <a:xfrm>
-            <a:off x="1695081" y="4432455"/>
-            <a:ext cx="2683042" cy="307736"/>
-          </a:xfrm>
-          <a:prstGeom prst="rect">
-            <a:avLst/>
-          </a:prstGeom>
-          <a:noFill/>
-          <a:ln>
-            <a:noFill/>
-          </a:ln>
-        </p:spPr>
-        <p:txBody>
-          <a:bodyPr spcFirstLastPara="1" wrap="square" lIns="91425" tIns="45700" rIns="91425" bIns="45700" anchor="t" anchorCtr="0">
-            <a:spAutoFit/>
-          </a:bodyPr>
-          <a:lstStyle/>
-          <a:p>
-            <a:pPr marL="0" marR="0" lvl="0" indent="0" algn="ctr" rtl="0">
-              <a:lnSpc>
-                <a:spcPct val="100000"/>
-              </a:lnSpc>
-              <a:spcBef>
-                <a:spcPts val="0"/>
-              </a:spcBef>
-              <a:spcAft>
-                <a:spcPts val="0"/>
-              </a:spcAft>
-              <a:buClr>
-                <a:srgbClr val="000000"/>
-              </a:buClr>
-              <a:buSzPts val="1400"/>
-              <a:buFont typeface="Arial"/>
-              <a:buNone/>
-            </a:pPr>
-            <a:r>
-              <a:rPr lang="fr-FR" sz="1400" b="1" i="0" u="none" strike="noStrike" cap="none" dirty="0" err="1">
-                <a:solidFill>
-                  <a:srgbClr val="41545E"/>
-                </a:solidFill>
-                <a:latin typeface="Arial"/>
-                <a:ea typeface="Arial"/>
-                <a:cs typeface="Arial"/>
-                <a:sym typeface="Arial"/>
-              </a:rPr>
-              <a:t>xxxx</a:t>
-            </a:r>
-            <a:endParaRPr sz="1400" b="0" i="0" u="none" strike="noStrike" cap="none" dirty="0">
-              <a:solidFill>
-                <a:srgbClr val="41545E"/>
-              </a:solidFill>
-              <a:latin typeface="Arial"/>
-              <a:ea typeface="Arial"/>
-              <a:cs typeface="Arial"/>
-              <a:sym typeface="Arial"/>
-            </a:endParaRPr>
-          </a:p>
-        </p:txBody>
-      </p:sp>
-    </p:spTree>
-    <p:extLst>
-      <p:ext uri="{BB962C8B-B14F-4D97-AF65-F5344CB8AC3E}">
-        <p14:creationId xmlns:p14="http://schemas.microsoft.com/office/powerpoint/2010/main" val="406580661"/>
-      </p:ext>
-    </p:extLst>
-  </p:cSld>
-  <p:clrMapOvr>
-    <a:masterClrMapping/>
-  </p:clrMapOvr>
-  <p:timing>
-    <p:tnLst>
-      <p:par>
-        <p:cTn id="1" dur="indefinite" restart="never" nodeType="tmRoot">
-          <p:childTnLst>
-            <p:seq concurrent="1" nextAc="seek">
-              <p:cTn id="2" dur="indefinite" nodeType="mainSeq">
-                <p:childTnLst>
-                  <p:par>
-                    <p:cTn id="3" fill="hold">
-                      <p:stCondLst>
-                        <p:cond delay="indefinite"/>
-                      </p:stCondLst>
-                      <p:childTnLst>
-                        <p:par>
-                          <p:cTn id="4" fill="hold">
-                            <p:stCondLst>
-                              <p:cond delay="0"/>
-                            </p:stCondLst>
-                            <p:childTnLst>
-                              <p:par>
-                                <p:cTn id="5" presetID="1" presetClass="entr" presetSubtype="0" fill="hold" grpId="0" nodeType="clickEffect">
-                                  <p:stCondLst>
-                                    <p:cond delay="0"/>
-                                  </p:stCondLst>
-                                  <p:childTnLst>
-                                    <p:set>
-                                      <p:cBhvr>
-                                        <p:cTn id="6" dur="1" fill="hold">
-                                          <p:stCondLst>
-                                            <p:cond delay="0"/>
-                                          </p:stCondLst>
-                                        </p:cTn>
-                                        <p:tgtEl>
-                                          <p:spTgt spid="74"/>
-                                        </p:tgtEl>
-                                        <p:attrNameLst>
-                                          <p:attrName>style.visibility</p:attrName>
-                                        </p:attrNameLst>
-                                      </p:cBhvr>
-                                      <p:to>
-                                        <p:strVal val="visible"/>
-                                      </p:to>
-                                    </p:set>
-                                  </p:childTnLst>
-                                </p:cTn>
-                              </p:par>
-                            </p:childTnLst>
-                          </p:cTn>
-                        </p:par>
-                      </p:childTnLst>
-                    </p:cTn>
-                  </p:par>
-                  <p:par>
-                    <p:cTn id="7" fill="hold">
-                      <p:stCondLst>
-                        <p:cond delay="indefinite"/>
-                      </p:stCondLst>
-                      <p:childTnLst>
-                        <p:par>
-                          <p:cTn id="8" fill="hold">
-                            <p:stCondLst>
-                              <p:cond delay="0"/>
-                            </p:stCondLst>
-                            <p:childTnLst>
-                              <p:par>
-                                <p:cTn id="9" presetID="1" presetClass="entr" presetSubtype="0" fill="hold" grpId="0" nodeType="clickEffect">
-                                  <p:stCondLst>
-                                    <p:cond delay="0"/>
-                                  </p:stCondLst>
-                                  <p:childTnLst>
-                                    <p:set>
-                                      <p:cBhvr>
-                                        <p:cTn id="10" dur="1" fill="hold">
-                                          <p:stCondLst>
-                                            <p:cond delay="0"/>
-                                          </p:stCondLst>
-                                        </p:cTn>
-                                        <p:tgtEl>
-                                          <p:spTgt spid="75"/>
-                                        </p:tgtEl>
-                                        <p:attrNameLst>
-                                          <p:attrName>style.visibility</p:attrName>
-                                        </p:attrNameLst>
-                                      </p:cBhvr>
-                                      <p:to>
-                                        <p:strVal val="visible"/>
-                                      </p:to>
-                                    </p:set>
-                                  </p:childTnLst>
-                                </p:cTn>
-                              </p:par>
-                            </p:childTnLst>
-                          </p:cTn>
-                        </p:par>
-                      </p:childTnLst>
-                    </p:cTn>
-                  </p:par>
-                  <p:par>
-                    <p:cTn id="11" fill="hold">
-                      <p:stCondLst>
-                        <p:cond delay="indefinite"/>
-                      </p:stCondLst>
-                      <p:childTnLst>
-                        <p:par>
-                          <p:cTn id="12" fill="hold">
-                            <p:stCondLst>
-                              <p:cond delay="0"/>
-                            </p:stCondLst>
-                            <p:childTnLst>
-                              <p:par>
-                                <p:cTn id="13" presetID="1" presetClass="entr" presetSubtype="0" fill="hold" grpId="0" nodeType="clickEffect">
-                                  <p:stCondLst>
-                                    <p:cond delay="0"/>
-                                  </p:stCondLst>
-                                  <p:childTnLst>
-                                    <p:set>
-                                      <p:cBhvr>
-                                        <p:cTn id="14" dur="1" fill="hold">
-                                          <p:stCondLst>
-                                            <p:cond delay="0"/>
-                                          </p:stCondLst>
-                                        </p:cTn>
-                                        <p:tgtEl>
-                                          <p:spTgt spid="77"/>
-                                        </p:tgtEl>
-                                        <p:attrNameLst>
-                                          <p:attrName>style.visibility</p:attrName>
-                                        </p:attrNameLst>
-                                      </p:cBhvr>
-                                      <p:to>
-                                        <p:strVal val="visible"/>
-                                      </p:to>
-                                    </p:set>
-                                  </p:childTnLst>
-                                </p:cTn>
-                              </p:par>
-                            </p:childTnLst>
-                          </p:cTn>
-                        </p:par>
-                      </p:childTnLst>
-                    </p:cTn>
-                  </p:par>
-                  <p:par>
-                    <p:cTn id="15" fill="hold">
-                      <p:stCondLst>
-                        <p:cond delay="indefinite"/>
-                      </p:stCondLst>
-                      <p:childTnLst>
-                        <p:par>
-                          <p:cTn id="16" fill="hold">
-                            <p:stCondLst>
-                              <p:cond delay="0"/>
-                            </p:stCondLst>
-                            <p:childTnLst>
-                              <p:par>
-                                <p:cTn id="17" presetID="1" presetClass="entr" presetSubtype="0" fill="hold" grpId="0" nodeType="clickEffect">
-                                  <p:stCondLst>
-                                    <p:cond delay="0"/>
-                                  </p:stCondLst>
-                                  <p:childTnLst>
-                                    <p:set>
-                                      <p:cBhvr>
-                                        <p:cTn id="18" dur="1" fill="hold">
-                                          <p:stCondLst>
-                                            <p:cond delay="0"/>
-                                          </p:stCondLst>
-                                        </p:cTn>
-                                        <p:tgtEl>
-                                          <p:spTgt spid="76"/>
-                                        </p:tgtEl>
-                                        <p:attrNameLst>
-                                          <p:attrName>style.visibility</p:attrName>
-                                        </p:attrNameLst>
-                                      </p:cBhvr>
-                                      <p:to>
-                                        <p:strVal val="visible"/>
-                                      </p:to>
-                                    </p:set>
-                                  </p:childTnLst>
-                                </p:cTn>
-                              </p:par>
-                            </p:childTnLst>
-                          </p:cTn>
-                        </p:par>
-                      </p:childTnLst>
-                    </p:cTn>
-                  </p:par>
-                </p:childTnLst>
-              </p:cTn>
-              <p:prevCondLst>
-                <p:cond evt="onPrev" delay="0">
-                  <p:tgtEl>
-                    <p:sldTgt/>
-                  </p:tgtEl>
-                </p:cond>
-              </p:prevCondLst>
-              <p:nextCondLst>
-                <p:cond evt="onNext" delay="0">
-                  <p:tgtEl>
-                    <p:sldTgt/>
-                  </p:tgtEl>
-                </p:cond>
-              </p:nextCondLst>
-            </p:seq>
-          </p:childTnLst>
-        </p:cTn>
-      </p:par>
-    </p:tnLst>
-    <p:bldLst>
-      <p:bldP spid="74" grpId="0" animBg="1"/>
-      <p:bldP spid="75" grpId="0"/>
-      <p:bldP spid="76" grpId="0"/>
-      <p:bldP spid="77" grpId="0"/>
-    </p:bldLst>
-  </p:timing>
-</p:sld>
-</file>
-
-<file path=ppt/slides/slide4.xml><?xml version="1.0" encoding="utf-8"?>
-<p:sld xmlns:a="http://schemas.openxmlformats.org/drawingml/2006/main" xmlns:r="http://schemas.openxmlformats.org/officeDocument/2006/relationships" xmlns:p="http://schemas.openxmlformats.org/presentationml/2006/main">
-  <p:cSld>
-    <p:spTree>
-      <p:nvGrpSpPr>
-        <p:cNvPr id="1" name="Shape 61">
-          <a:extLst>
-            <a:ext uri="{FF2B5EF4-FFF2-40B4-BE49-F238E27FC236}">
-              <a16:creationId xmlns:a16="http://schemas.microsoft.com/office/drawing/2014/main" id="{F8D5020C-5B29-41DB-36D0-3BA79EF327F5}"/>
-            </a:ext>
-          </a:extLst>
-        </p:cNvPr>
-        <p:cNvGrpSpPr/>
-        <p:nvPr/>
-      </p:nvGrpSpPr>
-      <p:grpSpPr>
-        <a:xfrm>
-          <a:off x="0" y="0"/>
-          <a:ext cx="0" cy="0"/>
-          <a:chOff x="0" y="0"/>
-          <a:chExt cx="0" cy="0"/>
-        </a:xfrm>
-      </p:grpSpPr>
-      <p:sp>
-        <p:nvSpPr>
-          <p:cNvPr id="62" name="Google Shape;62;p14">
-            <a:extLst>
-              <a:ext uri="{FF2B5EF4-FFF2-40B4-BE49-F238E27FC236}">
-                <a16:creationId xmlns:a16="http://schemas.microsoft.com/office/drawing/2014/main" id="{3343F25C-A672-5C3E-15CC-80C8FC016888}"/>
-              </a:ext>
-            </a:extLst>
-          </p:cNvPr>
-          <p:cNvSpPr txBox="1">
-            <a:spLocks noGrp="1"/>
-          </p:cNvSpPr>
-          <p:nvPr>
-            <p:ph type="ctrTitle" idx="4294967295"/>
-          </p:nvPr>
-        </p:nvSpPr>
-        <p:spPr>
-          <a:xfrm>
-            <a:off x="1040272" y="1702750"/>
-            <a:ext cx="5315100" cy="1398600"/>
-          </a:xfrm>
-          <a:prstGeom prst="rect">
-            <a:avLst/>
-          </a:prstGeom>
-        </p:spPr>
-        <p:txBody>
-          <a:bodyPr spcFirstLastPara="1" wrap="square" lIns="91425" tIns="91425" rIns="91425" bIns="91425" anchor="t" anchorCtr="0">
-            <a:noAutofit/>
-          </a:bodyPr>
-          <a:lstStyle/>
-          <a:p>
-            <a:pPr marL="0" lvl="0" indent="0" algn="l" rtl="0">
-              <a:spcBef>
-                <a:spcPts val="0"/>
-              </a:spcBef>
-              <a:spcAft>
-                <a:spcPts val="0"/>
-              </a:spcAft>
-              <a:buNone/>
-            </a:pPr>
-            <a:r>
-              <a:rPr lang="fr-FR" sz="4500" b="1">
-                <a:solidFill>
-                  <a:srgbClr val="0E3449"/>
-                </a:solidFill>
-                <a:latin typeface="Inter"/>
-                <a:ea typeface="Inter"/>
-                <a:cs typeface="Inter"/>
-                <a:sym typeface="Inter"/>
-              </a:rPr>
-              <a:t>Analyse </a:t>
-            </a:r>
-            <a:endParaRPr sz="4500" b="1">
-              <a:solidFill>
-                <a:srgbClr val="0E3449"/>
-              </a:solidFill>
-              <a:latin typeface="Inter"/>
-              <a:ea typeface="Inter"/>
-              <a:cs typeface="Inter"/>
-              <a:sym typeface="Inter"/>
-            </a:endParaRPr>
-          </a:p>
-          <a:p>
-            <a:pPr marL="0" lvl="0" indent="0" algn="l" rtl="0">
-              <a:spcBef>
-                <a:spcPts val="0"/>
-              </a:spcBef>
-              <a:spcAft>
-                <a:spcPts val="0"/>
-              </a:spcAft>
-              <a:buNone/>
-            </a:pPr>
-            <a:endParaRPr sz="4500" b="1">
-              <a:solidFill>
-                <a:srgbClr val="0E3449"/>
-              </a:solidFill>
-              <a:latin typeface="Inter"/>
-              <a:ea typeface="Inter"/>
-              <a:cs typeface="Inter"/>
-              <a:sym typeface="Inter"/>
-            </a:endParaRPr>
-          </a:p>
-        </p:txBody>
-      </p:sp>
-      <p:pic>
-        <p:nvPicPr>
-          <p:cNvPr id="63" name="Google Shape;63;p14">
-            <a:extLst>
-              <a:ext uri="{FF2B5EF4-FFF2-40B4-BE49-F238E27FC236}">
-                <a16:creationId xmlns:a16="http://schemas.microsoft.com/office/drawing/2014/main" id="{10954D65-2EBB-F688-894B-D880BCEA986F}"/>
-              </a:ext>
-            </a:extLst>
-          </p:cNvPr>
-          <p:cNvPicPr preferRelativeResize="0"/>
-          <p:nvPr/>
-        </p:nvPicPr>
-        <p:blipFill>
-          <a:blip r:embed="rId3">
-            <a:alphaModFix/>
-          </a:blip>
-          <a:stretch>
-            <a:fillRect/>
-          </a:stretch>
-        </p:blipFill>
-        <p:spPr>
-          <a:xfrm>
-            <a:off x="463375" y="482852"/>
-            <a:ext cx="576900" cy="385904"/>
-          </a:xfrm>
-          <a:prstGeom prst="rect">
-            <a:avLst/>
-          </a:prstGeom>
-          <a:noFill/>
-          <a:ln>
-            <a:noFill/>
-          </a:ln>
-        </p:spPr>
-      </p:pic>
-    </p:spTree>
-    <p:extLst>
-      <p:ext uri="{BB962C8B-B14F-4D97-AF65-F5344CB8AC3E}">
-        <p14:creationId xmlns:p14="http://schemas.microsoft.com/office/powerpoint/2010/main" val="2182015625"/>
-      </p:ext>
-    </p:extLst>
-  </p:cSld>
-  <p:clrMapOvr>
-    <a:masterClrMapping/>
-  </p:clrMapOvr>
-</p:sld>
-</file>
-
-<file path=ppt/slides/slide5.xml><?xml version="1.0" encoding="utf-8"?>
-<p:sld xmlns:a="http://schemas.openxmlformats.org/drawingml/2006/main" xmlns:r="http://schemas.openxmlformats.org/officeDocument/2006/relationships" xmlns:p="http://schemas.openxmlformats.org/presentationml/2006/main">
-  <p:cSld>
-    <p:spTree>
-      <p:nvGrpSpPr>
-        <p:cNvPr id="1" name="Shape 177"/>
-        <p:cNvGrpSpPr/>
-        <p:nvPr/>
-      </p:nvGrpSpPr>
-      <p:grpSpPr>
-        <a:xfrm>
-          <a:off x="0" y="0"/>
-          <a:ext cx="0" cy="0"/>
-          <a:chOff x="0" y="0"/>
-          <a:chExt cx="0" cy="0"/>
-        </a:xfrm>
-      </p:grpSpPr>
-      <p:sp>
-        <p:nvSpPr>
-          <p:cNvPr id="178" name="Google Shape;178;p8"/>
-          <p:cNvSpPr txBox="1">
-            <a:spLocks noGrp="1"/>
-          </p:cNvSpPr>
-          <p:nvPr>
-            <p:ph type="ctrTitle" idx="4294967295"/>
-          </p:nvPr>
-        </p:nvSpPr>
-        <p:spPr>
-          <a:xfrm>
-            <a:off x="1192664" y="403309"/>
-            <a:ext cx="5315100" cy="533100"/>
-          </a:xfrm>
-          <a:prstGeom prst="rect">
-            <a:avLst/>
-          </a:prstGeom>
-          <a:noFill/>
-          <a:ln>
-            <a:noFill/>
-          </a:ln>
-        </p:spPr>
-        <p:txBody>
-          <a:bodyPr spcFirstLastPara="1" wrap="square" lIns="91425" tIns="91425" rIns="91425" bIns="91425" anchor="t" anchorCtr="0">
-            <a:noAutofit/>
-          </a:bodyPr>
-          <a:lstStyle/>
-          <a:p>
-            <a:pPr marL="0" marR="0" lvl="0" indent="0" algn="l" rtl="0">
-              <a:lnSpc>
-                <a:spcPct val="100000"/>
-              </a:lnSpc>
-              <a:spcBef>
-                <a:spcPts val="0"/>
-              </a:spcBef>
-              <a:spcAft>
-                <a:spcPts val="0"/>
-              </a:spcAft>
-              <a:buClr>
-                <a:schemeClr val="dk1"/>
-              </a:buClr>
-              <a:buSzPts val="2800"/>
-              <a:buFont typeface="Arial"/>
-              <a:buNone/>
-            </a:pPr>
-            <a:r>
-              <a:rPr lang="fr" sz="2500" b="0" i="0" u="none" strike="noStrike" cap="none">
-                <a:solidFill>
-                  <a:srgbClr val="0E3449"/>
-                </a:solidFill>
-                <a:latin typeface="Inter SemiBold"/>
-                <a:ea typeface="Inter SemiBold"/>
-                <a:cs typeface="Inter SemiBold"/>
-                <a:sym typeface="Inter SemiBold"/>
-              </a:rPr>
-              <a:t>What’s next? </a:t>
-            </a:r>
-            <a:endParaRPr sz="2500" b="0" i="0" u="none" strike="noStrike" cap="none">
-              <a:solidFill>
-                <a:srgbClr val="0E3449"/>
-              </a:solidFill>
-              <a:latin typeface="Inter SemiBold"/>
-              <a:ea typeface="Inter SemiBold"/>
-              <a:cs typeface="Inter SemiBold"/>
-              <a:sym typeface="Inter SemiBold"/>
-            </a:endParaRPr>
-          </a:p>
-        </p:txBody>
-      </p:sp>
-      <p:pic>
-        <p:nvPicPr>
-          <p:cNvPr id="179" name="Google Shape;179;p8"/>
-          <p:cNvPicPr preferRelativeResize="0"/>
-          <p:nvPr/>
-        </p:nvPicPr>
-        <p:blipFill rotWithShape="1">
-          <a:blip r:embed="rId3">
-            <a:alphaModFix/>
-          </a:blip>
-          <a:srcRect/>
-          <a:stretch/>
-        </p:blipFill>
-        <p:spPr>
-          <a:xfrm>
-            <a:off x="463375" y="482852"/>
-            <a:ext cx="576900" cy="385904"/>
-          </a:xfrm>
-          <a:prstGeom prst="rect">
-            <a:avLst/>
-          </a:prstGeom>
-          <a:noFill/>
-          <a:ln>
-            <a:noFill/>
-          </a:ln>
-        </p:spPr>
-      </p:pic>
-      <p:sp>
-        <p:nvSpPr>
-          <p:cNvPr id="180" name="Google Shape;180;p8"/>
-          <p:cNvSpPr/>
-          <p:nvPr/>
-        </p:nvSpPr>
-        <p:spPr>
-          <a:xfrm>
-            <a:off x="10225" y="4892025"/>
-            <a:ext cx="9144000" cy="251400"/>
-          </a:xfrm>
-          <a:prstGeom prst="rect">
-            <a:avLst/>
-          </a:prstGeom>
-          <a:solidFill>
-            <a:srgbClr val="C3FFFC"/>
-          </a:solidFill>
-          <a:ln>
-            <a:noFill/>
-          </a:ln>
-        </p:spPr>
-        <p:txBody>
-          <a:bodyPr spcFirstLastPara="1" wrap="square" lIns="91425" tIns="91425" rIns="91425" bIns="91425" anchor="ctr" anchorCtr="0">
-            <a:noAutofit/>
-          </a:bodyPr>
-          <a:lstStyle/>
-          <a:p>
-            <a:pPr marL="0" marR="0" lvl="0" indent="0" algn="l" rtl="0">
-              <a:lnSpc>
-                <a:spcPct val="100000"/>
-              </a:lnSpc>
-              <a:spcBef>
-                <a:spcPts val="0"/>
-              </a:spcBef>
-              <a:spcAft>
-                <a:spcPts val="0"/>
-              </a:spcAft>
-              <a:buClr>
-                <a:srgbClr val="000000"/>
-              </a:buClr>
-              <a:buSzPts val="1400"/>
-              <a:buFont typeface="Arial"/>
-              <a:buNone/>
-            </a:pPr>
-            <a:endParaRPr sz="1400" b="0" i="0" u="none" strike="noStrike" cap="none">
-              <a:solidFill>
-                <a:srgbClr val="000000"/>
-              </a:solidFill>
-              <a:latin typeface="Arial"/>
-              <a:ea typeface="Arial"/>
-              <a:cs typeface="Arial"/>
-              <a:sym typeface="Arial"/>
-            </a:endParaRPr>
-          </a:p>
-        </p:txBody>
-      </p:sp>
-      <p:sp>
-        <p:nvSpPr>
-          <p:cNvPr id="181" name="Google Shape;181;p8"/>
           <p:cNvSpPr txBox="1">
             <a:spLocks noGrp="1"/>
           </p:cNvSpPr>
@@ -16613,158 +15802,9 @@
         </p:txBody>
       </p:sp>
     </p:spTree>
-  </p:cSld>
-  <p:clrMapOvr>
-    <a:masterClrMapping/>
-  </p:clrMapOvr>
-</p:sld>
-</file>
-
-<file path=ppt/slides/slide6.xml><?xml version="1.0" encoding="utf-8"?>
-<p:sld xmlns:a="http://schemas.openxmlformats.org/drawingml/2006/main" xmlns:r="http://schemas.openxmlformats.org/officeDocument/2006/relationships" xmlns:p="http://schemas.openxmlformats.org/presentationml/2006/main">
-  <p:cSld>
-    <p:spTree>
-      <p:nvGrpSpPr>
-        <p:cNvPr id="1" name="Shape 61">
-          <a:extLst>
-            <a:ext uri="{FF2B5EF4-FFF2-40B4-BE49-F238E27FC236}">
-              <a16:creationId xmlns:a16="http://schemas.microsoft.com/office/drawing/2014/main" id="{3BCB29B3-B3D2-DE90-1424-FBF05B3033AA}"/>
-            </a:ext>
-          </a:extLst>
-        </p:cNvPr>
-        <p:cNvGrpSpPr/>
-        <p:nvPr/>
-      </p:nvGrpSpPr>
-      <p:grpSpPr>
-        <a:xfrm>
-          <a:off x="0" y="0"/>
-          <a:ext cx="0" cy="0"/>
-          <a:chOff x="0" y="0"/>
-          <a:chExt cx="0" cy="0"/>
-        </a:xfrm>
-      </p:grpSpPr>
-      <p:sp>
-        <p:nvSpPr>
-          <p:cNvPr id="62" name="Google Shape;62;p14">
-            <a:extLst>
-              <a:ext uri="{FF2B5EF4-FFF2-40B4-BE49-F238E27FC236}">
-                <a16:creationId xmlns:a16="http://schemas.microsoft.com/office/drawing/2014/main" id="{1465D56F-7913-AD4E-8248-AEC9AC3FBC16}"/>
-              </a:ext>
-            </a:extLst>
-          </p:cNvPr>
-          <p:cNvSpPr txBox="1">
-            <a:spLocks noGrp="1"/>
-          </p:cNvSpPr>
-          <p:nvPr>
-            <p:ph type="ctrTitle" idx="4294967295"/>
-          </p:nvPr>
-        </p:nvSpPr>
-        <p:spPr>
-          <a:xfrm>
-            <a:off x="1040272" y="1702750"/>
-            <a:ext cx="5315100" cy="1398600"/>
-          </a:xfrm>
-          <a:prstGeom prst="rect">
-            <a:avLst/>
-          </a:prstGeom>
-        </p:spPr>
-        <p:txBody>
-          <a:bodyPr spcFirstLastPara="1" wrap="square" lIns="91425" tIns="91425" rIns="91425" bIns="91425" anchor="t" anchorCtr="0">
-            <a:noAutofit/>
-          </a:bodyPr>
-          <a:lstStyle/>
-          <a:p>
-            <a:pPr marL="0" lvl="0" indent="0" algn="l" rtl="0">
-              <a:spcBef>
-                <a:spcPts val="0"/>
-              </a:spcBef>
-              <a:spcAft>
-                <a:spcPts val="0"/>
-              </a:spcAft>
-              <a:buNone/>
-            </a:pPr>
-            <a:r>
-              <a:rPr lang="fr-FR" sz="4500" b="1">
-                <a:solidFill>
-                  <a:srgbClr val="0E3449"/>
-                </a:solidFill>
-                <a:latin typeface="Inter"/>
-                <a:ea typeface="Inter"/>
-                <a:cs typeface="Inter"/>
-                <a:sym typeface="Inter"/>
-              </a:rPr>
-              <a:t>Eléments méthodologiques</a:t>
-            </a:r>
-            <a:endParaRPr sz="4500" b="1">
-              <a:solidFill>
-                <a:srgbClr val="0E3449"/>
-              </a:solidFill>
-              <a:latin typeface="Inter"/>
-              <a:ea typeface="Inter"/>
-              <a:cs typeface="Inter"/>
-              <a:sym typeface="Inter"/>
-            </a:endParaRPr>
-          </a:p>
-          <a:p>
-            <a:pPr marL="0" lvl="0" indent="0" algn="l" rtl="0">
-              <a:spcBef>
-                <a:spcPts val="0"/>
-              </a:spcBef>
-              <a:spcAft>
-                <a:spcPts val="0"/>
-              </a:spcAft>
-              <a:buNone/>
-            </a:pPr>
-            <a:endParaRPr sz="4500" b="1">
-              <a:solidFill>
-                <a:srgbClr val="0E3449"/>
-              </a:solidFill>
-              <a:latin typeface="Inter"/>
-              <a:ea typeface="Inter"/>
-              <a:cs typeface="Inter"/>
-              <a:sym typeface="Inter"/>
-            </a:endParaRPr>
-          </a:p>
-        </p:txBody>
-      </p:sp>
-      <p:pic>
-        <p:nvPicPr>
-          <p:cNvPr id="63" name="Google Shape;63;p14">
-            <a:extLst>
-              <a:ext uri="{FF2B5EF4-FFF2-40B4-BE49-F238E27FC236}">
-                <a16:creationId xmlns:a16="http://schemas.microsoft.com/office/drawing/2014/main" id="{0E69C9FD-1E2B-ED3F-EE4F-0F766FA3F0C0}"/>
-              </a:ext>
-            </a:extLst>
-          </p:cNvPr>
-          <p:cNvPicPr preferRelativeResize="0"/>
-          <p:nvPr/>
-        </p:nvPicPr>
-        <p:blipFill>
-          <a:blip r:embed="rId3">
-            <a:alphaModFix/>
-          </a:blip>
-          <a:stretch>
-            <a:fillRect/>
-          </a:stretch>
-        </p:blipFill>
-        <p:spPr>
-          <a:xfrm>
-            <a:off x="463375" y="482852"/>
-            <a:ext cx="576900" cy="385904"/>
-          </a:xfrm>
-          <a:prstGeom prst="rect">
-            <a:avLst/>
-          </a:prstGeom>
-          <a:noFill/>
-          <a:ln>
-            <a:noFill/>
-          </a:ln>
-        </p:spPr>
-      </p:pic>
-    </p:spTree>
     <p:extLst>
       <p:ext uri="{BB962C8B-B14F-4D97-AF65-F5344CB8AC3E}">
-        <p14:creationId xmlns:p14="http://schemas.microsoft.com/office/powerpoint/2010/main" val="1023234914"/>
+        <p14:creationId xmlns:p14="http://schemas.microsoft.com/office/powerpoint/2010/main" val="406580661"/>
       </p:ext>
     </p:extLst>
   </p:cSld>
@@ -16774,7 +15814,7 @@
 </p:sld>
 </file>
 
-<file path=ppt/slides/slide7.xml><?xml version="1.0" encoding="utf-8"?>
+<file path=ppt/slides/slide4.xml><?xml version="1.0" encoding="utf-8"?>
 <p:sld xmlns:a="http://schemas.openxmlformats.org/drawingml/2006/main" xmlns:r="http://schemas.openxmlformats.org/officeDocument/2006/relationships" xmlns:p="http://schemas.openxmlformats.org/presentationml/2006/main">
   <p:cSld>
     <p:spTree>
@@ -16850,7 +15890,7 @@
               <a:buNone/>
             </a:pPr>
             <a:r>
-              <a:rPr lang="it-IT" sz="2500" b="1" i="0" u="none" strike="noStrike" cap="none">
+              <a:rPr lang="it-IT" sz="2500" b="1" i="0" u="none" strike="noStrike" cap="none" dirty="0">
                 <a:solidFill>
                   <a:srgbClr val="0E3449"/>
                 </a:solidFill>
@@ -16861,7 +15901,7 @@
               </a:rPr>
               <a:t>Pipeline data</a:t>
             </a:r>
-            <a:endParaRPr lang="it-IT" sz="2500" b="0" i="0" u="none" strike="noStrike" cap="none">
+            <a:endParaRPr lang="it-IT" sz="2500" b="0" i="0" u="none" strike="noStrike" cap="none" dirty="0">
               <a:solidFill>
                 <a:srgbClr val="0E3449"/>
               </a:solidFill>
@@ -16990,12 +16030,341 @@
         </p:blipFill>
         <p:spPr>
           <a:xfrm>
-            <a:off x="1192664" y="948632"/>
+            <a:off x="1040275" y="868756"/>
             <a:ext cx="7355393" cy="3933854"/>
           </a:xfrm>
           <a:prstGeom prst="rect">
             <a:avLst/>
           </a:prstGeom>
+        </p:spPr>
+      </p:pic>
+      <p:pic>
+        <p:nvPicPr>
+          <p:cNvPr id="1026" name="Picture 2">
+            <a:extLst>
+              <a:ext uri="{FF2B5EF4-FFF2-40B4-BE49-F238E27FC236}">
+                <a16:creationId xmlns:a16="http://schemas.microsoft.com/office/drawing/2014/main" id="{923FE2F2-F305-A7CE-975B-2A2BA912E4B7}"/>
+              </a:ext>
+            </a:extLst>
+          </p:cNvPr>
+          <p:cNvPicPr>
+            <a:picLocks noChangeAspect="1" noChangeArrowheads="1"/>
+          </p:cNvPicPr>
+          <p:nvPr/>
+        </p:nvPicPr>
+        <p:blipFill>
+          <a:blip r:embed="rId5">
+            <a:extLst>
+              <a:ext uri="{28A0092B-C50C-407E-A947-70E740481C1C}">
+                <a14:useLocalDpi xmlns:a14="http://schemas.microsoft.com/office/drawing/2010/main" val="0"/>
+              </a:ext>
+            </a:extLst>
+          </a:blip>
+          <a:srcRect/>
+          <a:stretch>
+            <a:fillRect/>
+          </a:stretch>
+        </p:blipFill>
+        <p:spPr bwMode="auto">
+          <a:xfrm>
+            <a:off x="9381968" y="3152805"/>
+            <a:ext cx="1080840" cy="1080840"/>
+          </a:xfrm>
+          <a:prstGeom prst="rect">
+            <a:avLst/>
+          </a:prstGeom>
+          <a:noFill/>
+          <a:extLst>
+            <a:ext uri="{909E8E84-426E-40DD-AFC4-6F175D3DCCD1}">
+              <a14:hiddenFill xmlns:a14="http://schemas.microsoft.com/office/drawing/2010/main">
+                <a:solidFill>
+                  <a:srgbClr val="FFFFFF"/>
+                </a:solidFill>
+              </a14:hiddenFill>
+            </a:ext>
+          </a:extLst>
+        </p:spPr>
+      </p:pic>
+      <p:pic>
+        <p:nvPicPr>
+          <p:cNvPr id="1028" name="Picture 4">
+            <a:extLst>
+              <a:ext uri="{FF2B5EF4-FFF2-40B4-BE49-F238E27FC236}">
+                <a16:creationId xmlns:a16="http://schemas.microsoft.com/office/drawing/2014/main" id="{D0C03EA7-EAD6-1A33-21AE-920B9121582F}"/>
+              </a:ext>
+            </a:extLst>
+          </p:cNvPr>
+          <p:cNvPicPr>
+            <a:picLocks noChangeAspect="1" noChangeArrowheads="1"/>
+          </p:cNvPicPr>
+          <p:nvPr/>
+        </p:nvPicPr>
+        <p:blipFill>
+          <a:blip r:embed="rId6">
+            <a:extLst>
+              <a:ext uri="{28A0092B-C50C-407E-A947-70E740481C1C}">
+                <a14:useLocalDpi xmlns:a14="http://schemas.microsoft.com/office/drawing/2010/main" val="0"/>
+              </a:ext>
+            </a:extLst>
+          </a:blip>
+          <a:srcRect/>
+          <a:stretch>
+            <a:fillRect/>
+          </a:stretch>
+        </p:blipFill>
+        <p:spPr bwMode="auto">
+          <a:xfrm>
+            <a:off x="9461911" y="2285310"/>
+            <a:ext cx="1470313" cy="840179"/>
+          </a:xfrm>
+          <a:prstGeom prst="rect">
+            <a:avLst/>
+          </a:prstGeom>
+          <a:noFill/>
+          <a:extLst>
+            <a:ext uri="{909E8E84-426E-40DD-AFC4-6F175D3DCCD1}">
+              <a14:hiddenFill xmlns:a14="http://schemas.microsoft.com/office/drawing/2010/main">
+                <a:solidFill>
+                  <a:srgbClr val="FFFFFF"/>
+                </a:solidFill>
+              </a14:hiddenFill>
+            </a:ext>
+          </a:extLst>
+        </p:spPr>
+      </p:pic>
+      <p:pic>
+        <p:nvPicPr>
+          <p:cNvPr id="1030" name="Picture 6">
+            <a:extLst>
+              <a:ext uri="{FF2B5EF4-FFF2-40B4-BE49-F238E27FC236}">
+                <a16:creationId xmlns:a16="http://schemas.microsoft.com/office/drawing/2014/main" id="{2941D76B-6840-C572-907F-F3680B66EBF7}"/>
+              </a:ext>
+            </a:extLst>
+          </p:cNvPr>
+          <p:cNvPicPr>
+            <a:picLocks noChangeAspect="1" noChangeArrowheads="1"/>
+          </p:cNvPicPr>
+          <p:nvPr/>
+        </p:nvPicPr>
+        <p:blipFill>
+          <a:blip r:embed="rId7">
+            <a:extLst>
+              <a:ext uri="{28A0092B-C50C-407E-A947-70E740481C1C}">
+                <a14:useLocalDpi xmlns:a14="http://schemas.microsoft.com/office/drawing/2010/main" val="0"/>
+              </a:ext>
+            </a:extLst>
+          </a:blip>
+          <a:srcRect/>
+          <a:stretch>
+            <a:fillRect/>
+          </a:stretch>
+        </p:blipFill>
+        <p:spPr bwMode="auto">
+          <a:xfrm>
+            <a:off x="9381968" y="1643023"/>
+            <a:ext cx="1008072" cy="736668"/>
+          </a:xfrm>
+          <a:prstGeom prst="rect">
+            <a:avLst/>
+          </a:prstGeom>
+          <a:noFill/>
+          <a:extLst>
+            <a:ext uri="{909E8E84-426E-40DD-AFC4-6F175D3DCCD1}">
+              <a14:hiddenFill xmlns:a14="http://schemas.microsoft.com/office/drawing/2010/main">
+                <a:solidFill>
+                  <a:srgbClr val="FFFFFF"/>
+                </a:solidFill>
+              </a14:hiddenFill>
+            </a:ext>
+          </a:extLst>
+        </p:spPr>
+      </p:pic>
+      <p:pic>
+        <p:nvPicPr>
+          <p:cNvPr id="1032" name="Picture 8">
+            <a:extLst>
+              <a:ext uri="{FF2B5EF4-FFF2-40B4-BE49-F238E27FC236}">
+                <a16:creationId xmlns:a16="http://schemas.microsoft.com/office/drawing/2014/main" id="{0AA62D0C-7533-F64F-5205-AC2C6EB164FE}"/>
+              </a:ext>
+            </a:extLst>
+          </p:cNvPr>
+          <p:cNvPicPr>
+            <a:picLocks noChangeAspect="1" noChangeArrowheads="1"/>
+          </p:cNvPicPr>
+          <p:nvPr/>
+        </p:nvPicPr>
+        <p:blipFill>
+          <a:blip r:embed="rId8">
+            <a:extLst>
+              <a:ext uri="{28A0092B-C50C-407E-A947-70E740481C1C}">
+                <a14:useLocalDpi xmlns:a14="http://schemas.microsoft.com/office/drawing/2010/main" val="0"/>
+              </a:ext>
+            </a:extLst>
+          </a:blip>
+          <a:srcRect/>
+          <a:stretch>
+            <a:fillRect/>
+          </a:stretch>
+        </p:blipFill>
+        <p:spPr bwMode="auto">
+          <a:xfrm>
+            <a:off x="9886004" y="1117302"/>
+            <a:ext cx="485958" cy="485958"/>
+          </a:xfrm>
+          <a:prstGeom prst="rect">
+            <a:avLst/>
+          </a:prstGeom>
+          <a:noFill/>
+          <a:extLst>
+            <a:ext uri="{909E8E84-426E-40DD-AFC4-6F175D3DCCD1}">
+              <a14:hiddenFill xmlns:a14="http://schemas.microsoft.com/office/drawing/2010/main">
+                <a:solidFill>
+                  <a:srgbClr val="FFFFFF"/>
+                </a:solidFill>
+              </a14:hiddenFill>
+            </a:ext>
+          </a:extLst>
+        </p:spPr>
+      </p:pic>
+      <p:pic>
+        <p:nvPicPr>
+          <p:cNvPr id="1034" name="Picture 10">
+            <a:extLst>
+              <a:ext uri="{FF2B5EF4-FFF2-40B4-BE49-F238E27FC236}">
+                <a16:creationId xmlns:a16="http://schemas.microsoft.com/office/drawing/2014/main" id="{748B16F9-6C53-91C1-4712-424BF6CE8989}"/>
+              </a:ext>
+            </a:extLst>
+          </p:cNvPr>
+          <p:cNvPicPr>
+            <a:picLocks noChangeAspect="1" noChangeArrowheads="1"/>
+          </p:cNvPicPr>
+          <p:nvPr/>
+        </p:nvPicPr>
+        <p:blipFill>
+          <a:blip r:embed="rId9">
+            <a:extLst>
+              <a:ext uri="{28A0092B-C50C-407E-A947-70E740481C1C}">
+                <a14:useLocalDpi xmlns:a14="http://schemas.microsoft.com/office/drawing/2010/main" val="0"/>
+              </a:ext>
+            </a:extLst>
+          </a:blip>
+          <a:srcRect/>
+          <a:stretch>
+            <a:fillRect/>
+          </a:stretch>
+        </p:blipFill>
+        <p:spPr bwMode="auto">
+          <a:xfrm>
+            <a:off x="9557987" y="499821"/>
+            <a:ext cx="656034" cy="656034"/>
+          </a:xfrm>
+          <a:prstGeom prst="rect">
+            <a:avLst/>
+          </a:prstGeom>
+          <a:noFill/>
+          <a:extLst>
+            <a:ext uri="{909E8E84-426E-40DD-AFC4-6F175D3DCCD1}">
+              <a14:hiddenFill xmlns:a14="http://schemas.microsoft.com/office/drawing/2010/main">
+                <a:solidFill>
+                  <a:srgbClr val="FFFFFF"/>
+                </a:solidFill>
+              </a14:hiddenFill>
+            </a:ext>
+          </a:extLst>
+        </p:spPr>
+      </p:pic>
+      <p:pic>
+        <p:nvPicPr>
+          <p:cNvPr id="1036" name="Picture 12">
+            <a:extLst>
+              <a:ext uri="{FF2B5EF4-FFF2-40B4-BE49-F238E27FC236}">
+                <a16:creationId xmlns:a16="http://schemas.microsoft.com/office/drawing/2014/main" id="{135630BC-F5F0-17C1-438A-A312C16997F8}"/>
+              </a:ext>
+            </a:extLst>
+          </p:cNvPr>
+          <p:cNvPicPr>
+            <a:picLocks noChangeAspect="1" noChangeArrowheads="1"/>
+          </p:cNvPicPr>
+          <p:nvPr/>
+        </p:nvPicPr>
+        <p:blipFill>
+          <a:blip r:embed="rId10">
+            <a:extLst>
+              <a:ext uri="{28A0092B-C50C-407E-A947-70E740481C1C}">
+                <a14:useLocalDpi xmlns:a14="http://schemas.microsoft.com/office/drawing/2010/main" val="0"/>
+              </a:ext>
+            </a:extLst>
+          </a:blip>
+          <a:srcRect/>
+          <a:stretch>
+            <a:fillRect/>
+          </a:stretch>
+        </p:blipFill>
+        <p:spPr bwMode="auto">
+          <a:xfrm>
+            <a:off x="9645557" y="-23982"/>
+            <a:ext cx="905699" cy="654116"/>
+          </a:xfrm>
+          <a:prstGeom prst="rect">
+            <a:avLst/>
+          </a:prstGeom>
+          <a:noFill/>
+          <a:extLst>
+            <a:ext uri="{909E8E84-426E-40DD-AFC4-6F175D3DCCD1}">
+              <a14:hiddenFill xmlns:a14="http://schemas.microsoft.com/office/drawing/2010/main">
+                <a:solidFill>
+                  <a:srgbClr val="FFFFFF"/>
+                </a:solidFill>
+              </a14:hiddenFill>
+            </a:ext>
+          </a:extLst>
+        </p:spPr>
+      </p:pic>
+      <p:pic>
+        <p:nvPicPr>
+          <p:cNvPr id="1038" name="Picture 14">
+            <a:extLst>
+              <a:ext uri="{FF2B5EF4-FFF2-40B4-BE49-F238E27FC236}">
+                <a16:creationId xmlns:a16="http://schemas.microsoft.com/office/drawing/2014/main" id="{1B3822DD-A0E9-A37F-0DE9-40781F1C3DF4}"/>
+              </a:ext>
+            </a:extLst>
+          </p:cNvPr>
+          <p:cNvPicPr>
+            <a:picLocks noChangeAspect="1" noChangeArrowheads="1"/>
+          </p:cNvPicPr>
+          <p:nvPr/>
+        </p:nvPicPr>
+        <p:blipFill>
+          <a:blip r:embed="rId11">
+            <a:extLst>
+              <a:ext uri="{28A0092B-C50C-407E-A947-70E740481C1C}">
+                <a14:useLocalDpi xmlns:a14="http://schemas.microsoft.com/office/drawing/2010/main" val="0"/>
+              </a:ext>
+            </a:extLst>
+          </a:blip>
+          <a:srcRect/>
+          <a:stretch>
+            <a:fillRect/>
+          </a:stretch>
+        </p:blipFill>
+        <p:spPr bwMode="auto">
+          <a:xfrm>
+            <a:off x="9179213" y="-560638"/>
+            <a:ext cx="1783953" cy="654116"/>
+          </a:xfrm>
+          <a:prstGeom prst="rect">
+            <a:avLst/>
+          </a:prstGeom>
+          <a:noFill/>
+          <a:extLst>
+            <a:ext uri="{909E8E84-426E-40DD-AFC4-6F175D3DCCD1}">
+              <a14:hiddenFill xmlns:a14="http://schemas.microsoft.com/office/drawing/2010/main">
+                <a:solidFill>
+                  <a:srgbClr val="FFFFFF"/>
+                </a:solidFill>
+              </a14:hiddenFill>
+            </a:ext>
+          </a:extLst>
         </p:spPr>
       </p:pic>
     </p:spTree>
@@ -17011,7 +16380,349 @@
 </p:sld>
 </file>
 
-<file path=ppt/slides/slide8.xml><?xml version="1.0" encoding="utf-8"?>
+<file path=ppt/slides/slide5.xml><?xml version="1.0" encoding="utf-8"?>
+<p:sld xmlns:a="http://schemas.openxmlformats.org/drawingml/2006/main" xmlns:r="http://schemas.openxmlformats.org/officeDocument/2006/relationships" xmlns:p="http://schemas.openxmlformats.org/presentationml/2006/main">
+  <p:cSld>
+    <p:spTree>
+      <p:nvGrpSpPr>
+        <p:cNvPr id="1" name="Shape 177"/>
+        <p:cNvGrpSpPr/>
+        <p:nvPr/>
+      </p:nvGrpSpPr>
+      <p:grpSpPr>
+        <a:xfrm>
+          <a:off x="0" y="0"/>
+          <a:ext cx="0" cy="0"/>
+          <a:chOff x="0" y="0"/>
+          <a:chExt cx="0" cy="0"/>
+        </a:xfrm>
+      </p:grpSpPr>
+      <p:sp>
+        <p:nvSpPr>
+          <p:cNvPr id="178" name="Google Shape;178;p8"/>
+          <p:cNvSpPr txBox="1">
+            <a:spLocks noGrp="1"/>
+          </p:cNvSpPr>
+          <p:nvPr>
+            <p:ph type="ctrTitle" idx="4294967295"/>
+          </p:nvPr>
+        </p:nvSpPr>
+        <p:spPr>
+          <a:xfrm>
+            <a:off x="1192664" y="403309"/>
+            <a:ext cx="5315100" cy="533100"/>
+          </a:xfrm>
+          <a:prstGeom prst="rect">
+            <a:avLst/>
+          </a:prstGeom>
+          <a:noFill/>
+          <a:ln>
+            <a:noFill/>
+          </a:ln>
+        </p:spPr>
+        <p:txBody>
+          <a:bodyPr spcFirstLastPara="1" wrap="square" lIns="91425" tIns="91425" rIns="91425" bIns="91425" anchor="t" anchorCtr="0">
+            <a:noAutofit/>
+          </a:bodyPr>
+          <a:lstStyle/>
+          <a:p>
+            <a:r>
+              <a:rPr lang="fr-FR" sz="2500" b="1" dirty="0">
+                <a:solidFill>
+                  <a:srgbClr val="0E3449"/>
+                </a:solidFill>
+                <a:latin typeface="Inter SemiBold"/>
+                <a:ea typeface="Inter SemiBold"/>
+              </a:rPr>
+              <a:t>Synthèse finale</a:t>
+            </a:r>
+            <a:endParaRPr sz="2500" b="1" dirty="0">
+              <a:solidFill>
+                <a:srgbClr val="0E3449"/>
+              </a:solidFill>
+              <a:latin typeface="Inter SemiBold"/>
+              <a:ea typeface="Inter SemiBold"/>
+              <a:sym typeface="Inter SemiBold"/>
+            </a:endParaRPr>
+          </a:p>
+        </p:txBody>
+      </p:sp>
+      <p:pic>
+        <p:nvPicPr>
+          <p:cNvPr id="179" name="Google Shape;179;p8"/>
+          <p:cNvPicPr preferRelativeResize="0"/>
+          <p:nvPr/>
+        </p:nvPicPr>
+        <p:blipFill rotWithShape="1">
+          <a:blip r:embed="rId3">
+            <a:alphaModFix/>
+          </a:blip>
+          <a:srcRect/>
+          <a:stretch/>
+        </p:blipFill>
+        <p:spPr>
+          <a:xfrm>
+            <a:off x="463375" y="482852"/>
+            <a:ext cx="576900" cy="385904"/>
+          </a:xfrm>
+          <a:prstGeom prst="rect">
+            <a:avLst/>
+          </a:prstGeom>
+          <a:noFill/>
+          <a:ln>
+            <a:noFill/>
+          </a:ln>
+        </p:spPr>
+      </p:pic>
+      <p:sp>
+        <p:nvSpPr>
+          <p:cNvPr id="180" name="Google Shape;180;p8"/>
+          <p:cNvSpPr/>
+          <p:nvPr/>
+        </p:nvSpPr>
+        <p:spPr>
+          <a:xfrm>
+            <a:off x="10225" y="4892025"/>
+            <a:ext cx="9144000" cy="251400"/>
+          </a:xfrm>
+          <a:prstGeom prst="rect">
+            <a:avLst/>
+          </a:prstGeom>
+          <a:solidFill>
+            <a:srgbClr val="C3FFFC"/>
+          </a:solidFill>
+          <a:ln>
+            <a:noFill/>
+          </a:ln>
+        </p:spPr>
+        <p:txBody>
+          <a:bodyPr spcFirstLastPara="1" wrap="square" lIns="91425" tIns="91425" rIns="91425" bIns="91425" anchor="ctr" anchorCtr="0">
+            <a:noAutofit/>
+          </a:bodyPr>
+          <a:lstStyle/>
+          <a:p>
+            <a:pPr marL="0" marR="0" lvl="0" indent="0" algn="l" rtl="0">
+              <a:lnSpc>
+                <a:spcPct val="100000"/>
+              </a:lnSpc>
+              <a:spcBef>
+                <a:spcPts val="0"/>
+              </a:spcBef>
+              <a:spcAft>
+                <a:spcPts val="0"/>
+              </a:spcAft>
+              <a:buClr>
+                <a:srgbClr val="000000"/>
+              </a:buClr>
+              <a:buSzPts val="1400"/>
+              <a:buFont typeface="Arial"/>
+              <a:buNone/>
+            </a:pPr>
+            <a:endParaRPr sz="1400" b="0" i="0" u="none" strike="noStrike" cap="none">
+              <a:solidFill>
+                <a:srgbClr val="000000"/>
+              </a:solidFill>
+              <a:latin typeface="Arial"/>
+              <a:ea typeface="Arial"/>
+              <a:cs typeface="Arial"/>
+              <a:sym typeface="Arial"/>
+            </a:endParaRPr>
+          </a:p>
+        </p:txBody>
+      </p:sp>
+      <p:sp>
+        <p:nvSpPr>
+          <p:cNvPr id="181" name="Google Shape;181;p8"/>
+          <p:cNvSpPr txBox="1">
+            <a:spLocks noGrp="1"/>
+          </p:cNvSpPr>
+          <p:nvPr>
+            <p:ph type="body" idx="1"/>
+          </p:nvPr>
+        </p:nvSpPr>
+        <p:spPr>
+          <a:xfrm>
+            <a:off x="311700" y="1155049"/>
+            <a:ext cx="8520600" cy="3585142"/>
+          </a:xfrm>
+          <a:prstGeom prst="rect">
+            <a:avLst/>
+          </a:prstGeom>
+          <a:noFill/>
+          <a:ln>
+            <a:noFill/>
+          </a:ln>
+        </p:spPr>
+        <p:txBody>
+          <a:bodyPr spcFirstLastPara="1" wrap="square" lIns="91425" tIns="91425" rIns="91425" bIns="91425" anchor="t" anchorCtr="0">
+            <a:noAutofit/>
+          </a:bodyPr>
+          <a:lstStyle/>
+          <a:p>
+            <a:pPr marL="114300" lvl="0" indent="0" algn="l" rtl="0">
+              <a:lnSpc>
+                <a:spcPct val="115000"/>
+              </a:lnSpc>
+              <a:spcBef>
+                <a:spcPts val="0"/>
+              </a:spcBef>
+              <a:spcAft>
+                <a:spcPts val="0"/>
+              </a:spcAft>
+              <a:buSzPts val="1800"/>
+              <a:buNone/>
+            </a:pPr>
+            <a:r>
+              <a:rPr lang="fr-FR" sz="1400" dirty="0" err="1"/>
+              <a:t>wwwww</a:t>
+            </a:r>
+            <a:endParaRPr sz="1400" dirty="0"/>
+          </a:p>
+        </p:txBody>
+      </p:sp>
+    </p:spTree>
+  </p:cSld>
+  <p:clrMapOvr>
+    <a:masterClrMapping/>
+  </p:clrMapOvr>
+</p:sld>
+</file>
+
+<file path=ppt/slides/slide6.xml><?xml version="1.0" encoding="utf-8"?>
+<p:sld xmlns:a="http://schemas.openxmlformats.org/drawingml/2006/main" xmlns:r="http://schemas.openxmlformats.org/officeDocument/2006/relationships" xmlns:p="http://schemas.openxmlformats.org/presentationml/2006/main">
+  <p:cSld>
+    <p:spTree>
+      <p:nvGrpSpPr>
+        <p:cNvPr id="1" name="Shape 61">
+          <a:extLst>
+            <a:ext uri="{FF2B5EF4-FFF2-40B4-BE49-F238E27FC236}">
+              <a16:creationId xmlns:a16="http://schemas.microsoft.com/office/drawing/2014/main" id="{3BCB29B3-B3D2-DE90-1424-FBF05B3033AA}"/>
+            </a:ext>
+          </a:extLst>
+        </p:cNvPr>
+        <p:cNvGrpSpPr/>
+        <p:nvPr/>
+      </p:nvGrpSpPr>
+      <p:grpSpPr>
+        <a:xfrm>
+          <a:off x="0" y="0"/>
+          <a:ext cx="0" cy="0"/>
+          <a:chOff x="0" y="0"/>
+          <a:chExt cx="0" cy="0"/>
+        </a:xfrm>
+      </p:grpSpPr>
+      <p:sp>
+        <p:nvSpPr>
+          <p:cNvPr id="62" name="Google Shape;62;p14">
+            <a:extLst>
+              <a:ext uri="{FF2B5EF4-FFF2-40B4-BE49-F238E27FC236}">
+                <a16:creationId xmlns:a16="http://schemas.microsoft.com/office/drawing/2014/main" id="{1465D56F-7913-AD4E-8248-AEC9AC3FBC16}"/>
+              </a:ext>
+            </a:extLst>
+          </p:cNvPr>
+          <p:cNvSpPr txBox="1">
+            <a:spLocks noGrp="1"/>
+          </p:cNvSpPr>
+          <p:nvPr>
+            <p:ph type="ctrTitle" idx="4294967295"/>
+          </p:nvPr>
+        </p:nvSpPr>
+        <p:spPr>
+          <a:xfrm>
+            <a:off x="1040272" y="1702750"/>
+            <a:ext cx="5315100" cy="1398600"/>
+          </a:xfrm>
+          <a:prstGeom prst="rect">
+            <a:avLst/>
+          </a:prstGeom>
+        </p:spPr>
+        <p:txBody>
+          <a:bodyPr spcFirstLastPara="1" wrap="square" lIns="91425" tIns="91425" rIns="91425" bIns="91425" anchor="t" anchorCtr="0">
+            <a:noAutofit/>
+          </a:bodyPr>
+          <a:lstStyle/>
+          <a:p>
+            <a:pPr marL="0" lvl="0" indent="0" algn="l" rtl="0">
+              <a:spcBef>
+                <a:spcPts val="0"/>
+              </a:spcBef>
+              <a:spcAft>
+                <a:spcPts val="0"/>
+              </a:spcAft>
+              <a:buNone/>
+            </a:pPr>
+            <a:r>
+              <a:rPr lang="fr-FR" sz="4500" b="1" dirty="0">
+                <a:solidFill>
+                  <a:srgbClr val="0E3449"/>
+                </a:solidFill>
+                <a:latin typeface="Inter"/>
+                <a:ea typeface="Inter"/>
+                <a:cs typeface="Inter"/>
+                <a:sym typeface="Inter"/>
+              </a:rPr>
+              <a:t>Annexes</a:t>
+            </a:r>
+            <a:endParaRPr sz="4500" b="1" dirty="0">
+              <a:solidFill>
+                <a:srgbClr val="0E3449"/>
+              </a:solidFill>
+              <a:latin typeface="Inter"/>
+              <a:ea typeface="Inter"/>
+              <a:cs typeface="Inter"/>
+              <a:sym typeface="Inter"/>
+            </a:endParaRPr>
+          </a:p>
+        </p:txBody>
+      </p:sp>
+      <p:pic>
+        <p:nvPicPr>
+          <p:cNvPr id="63" name="Google Shape;63;p14">
+            <a:extLst>
+              <a:ext uri="{FF2B5EF4-FFF2-40B4-BE49-F238E27FC236}">
+                <a16:creationId xmlns:a16="http://schemas.microsoft.com/office/drawing/2014/main" id="{0E69C9FD-1E2B-ED3F-EE4F-0F766FA3F0C0}"/>
+              </a:ext>
+            </a:extLst>
+          </p:cNvPr>
+          <p:cNvPicPr preferRelativeResize="0"/>
+          <p:nvPr/>
+        </p:nvPicPr>
+        <p:blipFill>
+          <a:blip r:embed="rId3">
+            <a:alphaModFix/>
+          </a:blip>
+          <a:stretch>
+            <a:fillRect/>
+          </a:stretch>
+        </p:blipFill>
+        <p:spPr>
+          <a:xfrm>
+            <a:off x="463375" y="482852"/>
+            <a:ext cx="576900" cy="385904"/>
+          </a:xfrm>
+          <a:prstGeom prst="rect">
+            <a:avLst/>
+          </a:prstGeom>
+          <a:noFill/>
+          <a:ln>
+            <a:noFill/>
+          </a:ln>
+        </p:spPr>
+      </p:pic>
+    </p:spTree>
+    <p:extLst>
+      <p:ext uri="{BB962C8B-B14F-4D97-AF65-F5344CB8AC3E}">
+        <p14:creationId xmlns:p14="http://schemas.microsoft.com/office/powerpoint/2010/main" val="1558646683"/>
+      </p:ext>
+    </p:extLst>
+  </p:cSld>
+  <p:clrMapOvr>
+    <a:masterClrMapping/>
+  </p:clrMapOvr>
+</p:sld>
+</file>
+
+<file path=ppt/slides/slide7.xml><?xml version="1.0" encoding="utf-8"?>
 <p:sld xmlns:a="http://schemas.openxmlformats.org/drawingml/2006/main" xmlns:r="http://schemas.openxmlformats.org/officeDocument/2006/relationships" xmlns:p="http://schemas.openxmlformats.org/presentationml/2006/main">
   <p:cSld>
     <p:spTree>
@@ -18047,7 +17758,7 @@
 </p:sld>
 </file>
 
-<file path=ppt/slides/slide9.xml><?xml version="1.0" encoding="utf-8"?>
+<file path=ppt/slides/slide8.xml><?xml version="1.0" encoding="utf-8"?>
 <p:sld xmlns:a="http://schemas.openxmlformats.org/drawingml/2006/main" xmlns:r="http://schemas.openxmlformats.org/officeDocument/2006/relationships" xmlns:p="http://schemas.openxmlformats.org/presentationml/2006/main">
   <p:cSld>
     <p:bg>

</xml_diff>